<commit_message>
Replace emoji logo with proper SALESCORE brand image
- Create salescore_logo.png with blue flame icon + bold SALESCORE text
- Add add_logo() helper using add_picture() instead of emoji text
- Apply logo image consistently across all slides (cover + inner)

https://claude.ai/code/session_01128ZWrykrfpjbRCAUPiQTq
</commit_message>
<xml_diff>
--- a/SALESCORE_営業生産性向上_提案資料.pptx
+++ b/SALESCORE_営業生産性向上_提案資料.pptx
@@ -3176,41 +3176,30 @@
           </a:p>
         </p:txBody>
       </p:sp>
-      <p:sp>
-        <p:nvSpPr>
-          <p:cNvPr id="4" name="TextBox 3"/>
-          <p:cNvSpPr txBox="1"/>
-          <p:nvPr/>
-        </p:nvSpPr>
-        <p:spPr>
-          <a:xfrm>
-            <a:off x="9144000" y="91440"/>
-            <a:ext cx="2651760" cy="548640"/>
-          </a:xfrm>
-          <a:prstGeom prst="rect">
-            <a:avLst/>
-          </a:prstGeom>
-          <a:noFill/>
-        </p:spPr>
-        <p:txBody>
-          <a:bodyPr wrap="square">
-            <a:spAutoFit/>
-          </a:bodyPr>
-          <a:lstStyle/>
-          <a:p>
-            <a:pPr algn="r"/>
-            <a:r>
-              <a:rPr sz="1800" b="1">
-                <a:solidFill>
-                  <a:srgbClr val="1E3A6E"/>
-                </a:solidFill>
-                <a:latin typeface="Noto Sans JP"/>
-              </a:rPr>
-              <a:t>🔥 SALESCORE</a:t>
-            </a:r>
-          </a:p>
-        </p:txBody>
-      </p:sp>
+      <p:pic>
+        <p:nvPicPr>
+          <p:cNvPr id="4" name="Picture 3" descr="salescore_logo.png"/>
+          <p:cNvPicPr>
+            <a:picLocks noChangeAspect="1"/>
+          </p:cNvPicPr>
+          <p:nvPr/>
+        </p:nvPicPr>
+        <p:blipFill>
+          <a:blip r:embed="rId2"/>
+          <a:stretch>
+            <a:fillRect/>
+          </a:stretch>
+        </p:blipFill>
+        <p:spPr>
+          <a:xfrm>
+            <a:off x="9875520" y="73152"/>
+            <a:ext cx="1920240" cy="566928"/>
+          </a:xfrm>
+          <a:prstGeom prst="rect">
+            <a:avLst/>
+          </a:prstGeom>
+        </p:spPr>
+      </p:pic>
       <p:sp>
         <p:nvSpPr>
           <p:cNvPr id="5" name="TextBox 4"/>
@@ -3483,85 +3472,33 @@
           </a:p>
         </p:txBody>
       </p:sp>
-      <p:sp>
-        <p:nvSpPr>
-          <p:cNvPr id="4" name="Rectangle 3"/>
-          <p:cNvSpPr/>
-          <p:nvPr/>
-        </p:nvSpPr>
-        <p:spPr>
-          <a:xfrm>
-            <a:off x="9601200" y="91440"/>
-            <a:ext cx="2194560" cy="548640"/>
-          </a:xfrm>
-          <a:prstGeom prst="rect">
-            <a:avLst/>
-          </a:prstGeom>
-          <a:noFill/>
-          <a:ln>
-            <a:noFill/>
-          </a:ln>
-        </p:spPr>
-        <p:style>
-          <a:lnRef idx="1">
-            <a:schemeClr val="accent1"/>
-          </a:lnRef>
-          <a:fillRef idx="3">
-            <a:schemeClr val="accent1"/>
-          </a:fillRef>
-          <a:effectRef idx="2">
-            <a:schemeClr val="accent1"/>
-          </a:effectRef>
-          <a:fontRef idx="minor">
-            <a:schemeClr val="lt1"/>
-          </a:fontRef>
-        </p:style>
-        <p:txBody>
-          <a:bodyPr rtlCol="0" anchor="ctr"/>
-          <a:lstStyle/>
-          <a:p>
-            <a:pPr algn="ctr"/>
-          </a:p>
-        </p:txBody>
-      </p:sp>
-      <p:sp>
-        <p:nvSpPr>
-          <p:cNvPr id="5" name="TextBox 4"/>
-          <p:cNvSpPr txBox="1"/>
-          <p:nvPr/>
-        </p:nvSpPr>
-        <p:spPr>
-          <a:xfrm>
-            <a:off x="9601200" y="91440"/>
-            <a:ext cx="2194560" cy="548640"/>
-          </a:xfrm>
-          <a:prstGeom prst="rect">
-            <a:avLst/>
-          </a:prstGeom>
-          <a:noFill/>
-        </p:spPr>
-        <p:txBody>
-          <a:bodyPr wrap="square">
-            <a:spAutoFit/>
-          </a:bodyPr>
-          <a:lstStyle/>
-          <a:p>
-            <a:pPr algn="r"/>
-            <a:r>
-              <a:rPr sz="1600" b="1">
-                <a:solidFill>
-                  <a:srgbClr val="1E3A6E"/>
-                </a:solidFill>
-                <a:latin typeface="Noto Sans JP"/>
-              </a:rPr>
-              <a:t>🔥 SALESCORE</a:t>
-            </a:r>
-          </a:p>
-        </p:txBody>
-      </p:sp>
-      <p:sp>
-        <p:nvSpPr>
-          <p:cNvPr id="6" name="Rectangle 5"/>
+      <p:pic>
+        <p:nvPicPr>
+          <p:cNvPr id="4" name="Picture 3" descr="salescore_logo.png"/>
+          <p:cNvPicPr>
+            <a:picLocks noChangeAspect="1"/>
+          </p:cNvPicPr>
+          <p:nvPr/>
+        </p:nvPicPr>
+        <p:blipFill>
+          <a:blip r:embed="rId2"/>
+          <a:stretch>
+            <a:fillRect/>
+          </a:stretch>
+        </p:blipFill>
+        <p:spPr>
+          <a:xfrm>
+            <a:off x="9875520" y="73152"/>
+            <a:ext cx="1920240" cy="566928"/>
+          </a:xfrm>
+          <a:prstGeom prst="rect">
+            <a:avLst/>
+          </a:prstGeom>
+        </p:spPr>
+      </p:pic>
+      <p:sp>
+        <p:nvSpPr>
+          <p:cNvPr id="5" name="Rectangle 4"/>
           <p:cNvSpPr/>
           <p:nvPr/>
         </p:nvSpPr>
@@ -3604,7 +3541,7 @@
       </p:sp>
       <p:sp>
         <p:nvSpPr>
-          <p:cNvPr id="7" name="TextBox 6"/>
+          <p:cNvPr id="6" name="TextBox 5"/>
           <p:cNvSpPr txBox="1"/>
           <p:nvPr/>
         </p:nvSpPr>
@@ -3639,7 +3576,7 @@
       </p:sp>
       <p:sp>
         <p:nvSpPr>
-          <p:cNvPr id="8" name="TextBox 7"/>
+          <p:cNvPr id="7" name="TextBox 6"/>
           <p:cNvSpPr txBox="1"/>
           <p:nvPr/>
         </p:nvSpPr>
@@ -3674,7 +3611,7 @@
       </p:sp>
       <p:sp>
         <p:nvSpPr>
-          <p:cNvPr id="9" name="Rectangle 8"/>
+          <p:cNvPr id="8" name="Rectangle 7"/>
           <p:cNvSpPr/>
           <p:nvPr/>
         </p:nvSpPr>
@@ -3725,7 +3662,7 @@
       </p:sp>
       <p:sp>
         <p:nvSpPr>
-          <p:cNvPr id="10" name="TextBox 9"/>
+          <p:cNvPr id="9" name="TextBox 8"/>
           <p:cNvSpPr txBox="1"/>
           <p:nvPr/>
         </p:nvSpPr>
@@ -3760,7 +3697,7 @@
       </p:sp>
       <p:sp>
         <p:nvSpPr>
-          <p:cNvPr id="11" name="Rectangle 10"/>
+          <p:cNvPr id="10" name="Rectangle 9"/>
           <p:cNvSpPr/>
           <p:nvPr/>
         </p:nvSpPr>
@@ -3811,7 +3748,7 @@
       </p:sp>
       <p:sp>
         <p:nvSpPr>
-          <p:cNvPr id="12" name="Rectangle 11"/>
+          <p:cNvPr id="11" name="Rectangle 10"/>
           <p:cNvSpPr/>
           <p:nvPr/>
         </p:nvSpPr>
@@ -3856,7 +3793,7 @@
       </p:sp>
       <p:sp>
         <p:nvSpPr>
-          <p:cNvPr id="13" name="Rectangle 12"/>
+          <p:cNvPr id="12" name="Rectangle 11"/>
           <p:cNvSpPr/>
           <p:nvPr/>
         </p:nvSpPr>
@@ -3907,7 +3844,7 @@
       </p:sp>
       <p:sp>
         <p:nvSpPr>
-          <p:cNvPr id="14" name="TextBox 13"/>
+          <p:cNvPr id="13" name="TextBox 12"/>
           <p:cNvSpPr txBox="1"/>
           <p:nvPr/>
         </p:nvSpPr>
@@ -3943,7 +3880,7 @@
       </p:sp>
       <p:sp>
         <p:nvSpPr>
-          <p:cNvPr id="15" name="Rectangle 14"/>
+          <p:cNvPr id="14" name="Rectangle 13"/>
           <p:cNvSpPr/>
           <p:nvPr/>
         </p:nvSpPr>
@@ -3988,7 +3925,7 @@
       </p:sp>
       <p:sp>
         <p:nvSpPr>
-          <p:cNvPr id="16" name="Rectangle 15"/>
+          <p:cNvPr id="15" name="Rectangle 14"/>
           <p:cNvSpPr/>
           <p:nvPr/>
         </p:nvSpPr>
@@ -4039,7 +3976,7 @@
       </p:sp>
       <p:sp>
         <p:nvSpPr>
-          <p:cNvPr id="17" name="TextBox 16"/>
+          <p:cNvPr id="16" name="TextBox 15"/>
           <p:cNvSpPr txBox="1"/>
           <p:nvPr/>
         </p:nvSpPr>
@@ -4075,7 +4012,7 @@
       </p:sp>
       <p:sp>
         <p:nvSpPr>
-          <p:cNvPr id="18" name="Rectangle 17"/>
+          <p:cNvPr id="17" name="Rectangle 16"/>
           <p:cNvSpPr/>
           <p:nvPr/>
         </p:nvSpPr>
@@ -4120,7 +4057,7 @@
       </p:sp>
       <p:sp>
         <p:nvSpPr>
-          <p:cNvPr id="19" name="Rectangle 18"/>
+          <p:cNvPr id="18" name="Rectangle 17"/>
           <p:cNvSpPr/>
           <p:nvPr/>
         </p:nvSpPr>
@@ -4171,7 +4108,7 @@
       </p:sp>
       <p:sp>
         <p:nvSpPr>
-          <p:cNvPr id="20" name="TextBox 19"/>
+          <p:cNvPr id="19" name="TextBox 18"/>
           <p:cNvSpPr txBox="1"/>
           <p:nvPr/>
         </p:nvSpPr>
@@ -4207,7 +4144,7 @@
       </p:sp>
       <p:sp>
         <p:nvSpPr>
-          <p:cNvPr id="21" name="Rectangle 20"/>
+          <p:cNvPr id="20" name="Rectangle 19"/>
           <p:cNvSpPr/>
           <p:nvPr/>
         </p:nvSpPr>
@@ -4258,7 +4195,7 @@
       </p:sp>
       <p:sp>
         <p:nvSpPr>
-          <p:cNvPr id="22" name="TextBox 21"/>
+          <p:cNvPr id="21" name="TextBox 20"/>
           <p:cNvSpPr txBox="1"/>
           <p:nvPr/>
         </p:nvSpPr>
@@ -4293,7 +4230,7 @@
       </p:sp>
       <p:sp>
         <p:nvSpPr>
-          <p:cNvPr id="23" name="Rectangle 22"/>
+          <p:cNvPr id="22" name="Rectangle 21"/>
           <p:cNvSpPr/>
           <p:nvPr/>
         </p:nvSpPr>
@@ -4344,7 +4281,7 @@
       </p:sp>
       <p:sp>
         <p:nvSpPr>
-          <p:cNvPr id="24" name="TextBox 23"/>
+          <p:cNvPr id="23" name="TextBox 22"/>
           <p:cNvSpPr txBox="1"/>
           <p:nvPr/>
         </p:nvSpPr>
@@ -4379,7 +4316,7 @@
       </p:sp>
       <p:sp>
         <p:nvSpPr>
-          <p:cNvPr id="25" name="Rectangle 24"/>
+          <p:cNvPr id="24" name="Rectangle 23"/>
           <p:cNvSpPr/>
           <p:nvPr/>
         </p:nvSpPr>
@@ -4430,7 +4367,7 @@
       </p:sp>
       <p:sp>
         <p:nvSpPr>
-          <p:cNvPr id="26" name="Rectangle 25"/>
+          <p:cNvPr id="25" name="Rectangle 24"/>
           <p:cNvSpPr/>
           <p:nvPr/>
         </p:nvSpPr>
@@ -4475,7 +4412,7 @@
       </p:sp>
       <p:sp>
         <p:nvSpPr>
-          <p:cNvPr id="27" name="TextBox 26"/>
+          <p:cNvPr id="26" name="TextBox 25"/>
           <p:cNvSpPr txBox="1"/>
           <p:nvPr/>
         </p:nvSpPr>
@@ -4605,85 +4542,33 @@
           </a:p>
         </p:txBody>
       </p:sp>
-      <p:sp>
-        <p:nvSpPr>
-          <p:cNvPr id="4" name="Rectangle 3"/>
-          <p:cNvSpPr/>
-          <p:nvPr/>
-        </p:nvSpPr>
-        <p:spPr>
-          <a:xfrm>
-            <a:off x="9601200" y="91440"/>
-            <a:ext cx="2194560" cy="548640"/>
-          </a:xfrm>
-          <a:prstGeom prst="rect">
-            <a:avLst/>
-          </a:prstGeom>
-          <a:noFill/>
-          <a:ln>
-            <a:noFill/>
-          </a:ln>
-        </p:spPr>
-        <p:style>
-          <a:lnRef idx="1">
-            <a:schemeClr val="accent1"/>
-          </a:lnRef>
-          <a:fillRef idx="3">
-            <a:schemeClr val="accent1"/>
-          </a:fillRef>
-          <a:effectRef idx="2">
-            <a:schemeClr val="accent1"/>
-          </a:effectRef>
-          <a:fontRef idx="minor">
-            <a:schemeClr val="lt1"/>
-          </a:fontRef>
-        </p:style>
-        <p:txBody>
-          <a:bodyPr rtlCol="0" anchor="ctr"/>
-          <a:lstStyle/>
-          <a:p>
-            <a:pPr algn="ctr"/>
-          </a:p>
-        </p:txBody>
-      </p:sp>
-      <p:sp>
-        <p:nvSpPr>
-          <p:cNvPr id="5" name="TextBox 4"/>
-          <p:cNvSpPr txBox="1"/>
-          <p:nvPr/>
-        </p:nvSpPr>
-        <p:spPr>
-          <a:xfrm>
-            <a:off x="9601200" y="91440"/>
-            <a:ext cx="2194560" cy="548640"/>
-          </a:xfrm>
-          <a:prstGeom prst="rect">
-            <a:avLst/>
-          </a:prstGeom>
-          <a:noFill/>
-        </p:spPr>
-        <p:txBody>
-          <a:bodyPr wrap="square">
-            <a:spAutoFit/>
-          </a:bodyPr>
-          <a:lstStyle/>
-          <a:p>
-            <a:pPr algn="r"/>
-            <a:r>
-              <a:rPr sz="1600" b="1">
-                <a:solidFill>
-                  <a:srgbClr val="1E3A6E"/>
-                </a:solidFill>
-                <a:latin typeface="Noto Sans JP"/>
-              </a:rPr>
-              <a:t>🔥 SALESCORE</a:t>
-            </a:r>
-          </a:p>
-        </p:txBody>
-      </p:sp>
-      <p:sp>
-        <p:nvSpPr>
-          <p:cNvPr id="6" name="Rectangle 5"/>
+      <p:pic>
+        <p:nvPicPr>
+          <p:cNvPr id="4" name="Picture 3" descr="salescore_logo.png"/>
+          <p:cNvPicPr>
+            <a:picLocks noChangeAspect="1"/>
+          </p:cNvPicPr>
+          <p:nvPr/>
+        </p:nvPicPr>
+        <p:blipFill>
+          <a:blip r:embed="rId2"/>
+          <a:stretch>
+            <a:fillRect/>
+          </a:stretch>
+        </p:blipFill>
+        <p:spPr>
+          <a:xfrm>
+            <a:off x="9875520" y="73152"/>
+            <a:ext cx="1920240" cy="566928"/>
+          </a:xfrm>
+          <a:prstGeom prst="rect">
+            <a:avLst/>
+          </a:prstGeom>
+        </p:spPr>
+      </p:pic>
+      <p:sp>
+        <p:nvSpPr>
+          <p:cNvPr id="5" name="Rectangle 4"/>
           <p:cNvSpPr/>
           <p:nvPr/>
         </p:nvSpPr>
@@ -4726,7 +4611,7 @@
       </p:sp>
       <p:sp>
         <p:nvSpPr>
-          <p:cNvPr id="7" name="TextBox 6"/>
+          <p:cNvPr id="6" name="TextBox 5"/>
           <p:cNvSpPr txBox="1"/>
           <p:nvPr/>
         </p:nvSpPr>
@@ -4761,7 +4646,7 @@
       </p:sp>
       <p:sp>
         <p:nvSpPr>
-          <p:cNvPr id="8" name="TextBox 7"/>
+          <p:cNvPr id="7" name="TextBox 6"/>
           <p:cNvSpPr txBox="1"/>
           <p:nvPr/>
         </p:nvSpPr>
@@ -4796,7 +4681,7 @@
       </p:sp>
       <p:sp>
         <p:nvSpPr>
-          <p:cNvPr id="9" name="TextBox 8"/>
+          <p:cNvPr id="8" name="TextBox 7"/>
           <p:cNvSpPr txBox="1"/>
           <p:nvPr/>
         </p:nvSpPr>
@@ -4831,7 +4716,7 @@
       </p:sp>
       <p:sp>
         <p:nvSpPr>
-          <p:cNvPr id="10" name="TextBox 9"/>
+          <p:cNvPr id="9" name="TextBox 8"/>
           <p:cNvSpPr txBox="1"/>
           <p:nvPr/>
         </p:nvSpPr>
@@ -4866,7 +4751,7 @@
       </p:sp>
       <p:sp>
         <p:nvSpPr>
-          <p:cNvPr id="11" name="Rectangle 10"/>
+          <p:cNvPr id="10" name="Rectangle 9"/>
           <p:cNvSpPr/>
           <p:nvPr/>
         </p:nvSpPr>
@@ -4909,7 +4794,7 @@
       </p:sp>
       <p:sp>
         <p:nvSpPr>
-          <p:cNvPr id="12" name="TextBox 11"/>
+          <p:cNvPr id="11" name="TextBox 10"/>
           <p:cNvSpPr txBox="1"/>
           <p:nvPr/>
         </p:nvSpPr>
@@ -4947,7 +4832,7 @@
       </p:sp>
       <p:sp>
         <p:nvSpPr>
-          <p:cNvPr id="13" name="TextBox 12"/>
+          <p:cNvPr id="12" name="TextBox 11"/>
           <p:cNvSpPr txBox="1"/>
           <p:nvPr/>
         </p:nvSpPr>
@@ -4982,7 +4867,7 @@
       </p:sp>
       <p:sp>
         <p:nvSpPr>
-          <p:cNvPr id="14" name="Rectangle 13"/>
+          <p:cNvPr id="13" name="Rectangle 12"/>
           <p:cNvSpPr/>
           <p:nvPr/>
         </p:nvSpPr>
@@ -5025,7 +4910,7 @@
       </p:sp>
       <p:sp>
         <p:nvSpPr>
-          <p:cNvPr id="15" name="TextBox 14"/>
+          <p:cNvPr id="14" name="TextBox 13"/>
           <p:cNvSpPr txBox="1"/>
           <p:nvPr/>
         </p:nvSpPr>
@@ -5063,7 +4948,7 @@
       </p:sp>
       <p:sp>
         <p:nvSpPr>
-          <p:cNvPr id="16" name="TextBox 15"/>
+          <p:cNvPr id="15" name="TextBox 14"/>
           <p:cNvSpPr txBox="1"/>
           <p:nvPr/>
         </p:nvSpPr>
@@ -5098,7 +4983,7 @@
       </p:sp>
       <p:sp>
         <p:nvSpPr>
-          <p:cNvPr id="17" name="Rectangle 16"/>
+          <p:cNvPr id="16" name="Rectangle 15"/>
           <p:cNvSpPr/>
           <p:nvPr/>
         </p:nvSpPr>
@@ -5141,7 +5026,7 @@
       </p:sp>
       <p:sp>
         <p:nvSpPr>
-          <p:cNvPr id="18" name="TextBox 17"/>
+          <p:cNvPr id="17" name="TextBox 16"/>
           <p:cNvSpPr txBox="1"/>
           <p:nvPr/>
         </p:nvSpPr>
@@ -5179,7 +5064,7 @@
       </p:sp>
       <p:sp>
         <p:nvSpPr>
-          <p:cNvPr id="19" name="TextBox 18"/>
+          <p:cNvPr id="18" name="TextBox 17"/>
           <p:cNvSpPr txBox="1"/>
           <p:nvPr/>
         </p:nvSpPr>
@@ -5216,7 +5101,7 @@
       </p:sp>
       <p:sp>
         <p:nvSpPr>
-          <p:cNvPr id="20" name="TextBox 19"/>
+          <p:cNvPr id="19" name="TextBox 18"/>
           <p:cNvSpPr txBox="1"/>
           <p:nvPr/>
         </p:nvSpPr>
@@ -5253,7 +5138,7 @@
       </p:sp>
       <p:sp>
         <p:nvSpPr>
-          <p:cNvPr id="21" name="TextBox 20"/>
+          <p:cNvPr id="20" name="TextBox 19"/>
           <p:cNvSpPr txBox="1"/>
           <p:nvPr/>
         </p:nvSpPr>
@@ -5290,7 +5175,7 @@
       </p:sp>
       <p:sp>
         <p:nvSpPr>
-          <p:cNvPr id="22" name="Rectangle 21"/>
+          <p:cNvPr id="21" name="Rectangle 20"/>
           <p:cNvSpPr/>
           <p:nvPr/>
         </p:nvSpPr>
@@ -5335,7 +5220,7 @@
       </p:sp>
       <p:sp>
         <p:nvSpPr>
-          <p:cNvPr id="23" name="Rectangle 22"/>
+          <p:cNvPr id="22" name="Rectangle 21"/>
           <p:cNvSpPr/>
           <p:nvPr/>
         </p:nvSpPr>
@@ -5387,7 +5272,7 @@
       </p:sp>
       <p:sp>
         <p:nvSpPr>
-          <p:cNvPr id="24" name="TextBox 23"/>
+          <p:cNvPr id="23" name="TextBox 22"/>
           <p:cNvSpPr txBox="1"/>
           <p:nvPr/>
         </p:nvSpPr>
@@ -5423,7 +5308,7 @@
       </p:sp>
       <p:sp>
         <p:nvSpPr>
-          <p:cNvPr id="25" name="Rectangle 24"/>
+          <p:cNvPr id="24" name="Rectangle 23"/>
           <p:cNvSpPr/>
           <p:nvPr/>
         </p:nvSpPr>
@@ -5468,7 +5353,7 @@
       </p:sp>
       <p:sp>
         <p:nvSpPr>
-          <p:cNvPr id="26" name="Rectangle 25"/>
+          <p:cNvPr id="25" name="Rectangle 24"/>
           <p:cNvSpPr/>
           <p:nvPr/>
         </p:nvSpPr>
@@ -5520,7 +5405,7 @@
       </p:sp>
       <p:sp>
         <p:nvSpPr>
-          <p:cNvPr id="27" name="TextBox 26"/>
+          <p:cNvPr id="26" name="TextBox 25"/>
           <p:cNvSpPr txBox="1"/>
           <p:nvPr/>
         </p:nvSpPr>
@@ -5556,7 +5441,7 @@
       </p:sp>
       <p:sp>
         <p:nvSpPr>
-          <p:cNvPr id="28" name="Rectangle 27"/>
+          <p:cNvPr id="27" name="Rectangle 26"/>
           <p:cNvSpPr/>
           <p:nvPr/>
         </p:nvSpPr>
@@ -5601,7 +5486,7 @@
       </p:sp>
       <p:sp>
         <p:nvSpPr>
-          <p:cNvPr id="29" name="Rectangle 28"/>
+          <p:cNvPr id="28" name="Rectangle 27"/>
           <p:cNvSpPr/>
           <p:nvPr/>
         </p:nvSpPr>
@@ -5653,7 +5538,7 @@
       </p:sp>
       <p:sp>
         <p:nvSpPr>
-          <p:cNvPr id="30" name="TextBox 29"/>
+          <p:cNvPr id="29" name="TextBox 28"/>
           <p:cNvSpPr txBox="1"/>
           <p:nvPr/>
         </p:nvSpPr>

</xml_diff>

<commit_message>
Consulting-quality slide redesign + improved logo
- Full redesign inspired by Abeam/Accenture style
- Cover: split navy panel (left) / white content (right) layout
- Inner slides: generous margins, refined typography hierarchy
- Problem slide: detailed 3-issue cards + annotated bar chart + so-what box
- Solution slide: clean 3-column action flow with benefit boxes
- Improved logo: better flame icon approximation, white variant added
- Consistent color palette: NAVY_DEEP / NAVY / BLUE / subtle grays

https://claude.ai/code/session_01128ZWrykrfpjbRCAUPiQTq
</commit_message>
<xml_diff>
--- a/SALESCORE_営業生産性向上_提案資料.pptx
+++ b/SALESCORE_営業生産性向上_提案資料.pptx
@@ -3098,14 +3098,14 @@
         </p:nvSpPr>
         <p:spPr>
           <a:xfrm>
-            <a:off x="365760" y="685800"/>
-            <a:ext cx="11430000" cy="19050"/>
+            <a:off x="0" y="0"/>
+            <a:ext cx="4206240" cy="6858000"/>
           </a:xfrm>
           <a:prstGeom prst="rect">
             <a:avLst/>
           </a:prstGeom>
           <a:solidFill>
-            <a:srgbClr val="000000"/>
+            <a:srgbClr val="0C1A4B"/>
           </a:solidFill>
           <a:ln>
             <a:noFill/>
@@ -3133,52 +3133,9 @@
           </a:p>
         </p:txBody>
       </p:sp>
-      <p:sp>
-        <p:nvSpPr>
-          <p:cNvPr id="3" name="Rectangle 2"/>
-          <p:cNvSpPr/>
-          <p:nvPr/>
-        </p:nvSpPr>
-        <p:spPr>
-          <a:xfrm>
-            <a:off x="365760" y="6400800"/>
-            <a:ext cx="11430000" cy="19050"/>
-          </a:xfrm>
-          <a:prstGeom prst="rect">
-            <a:avLst/>
-          </a:prstGeom>
-          <a:solidFill>
-            <a:srgbClr val="000000"/>
-          </a:solidFill>
-          <a:ln>
-            <a:noFill/>
-          </a:ln>
-        </p:spPr>
-        <p:style>
-          <a:lnRef idx="1">
-            <a:schemeClr val="accent1"/>
-          </a:lnRef>
-          <a:fillRef idx="3">
-            <a:schemeClr val="accent1"/>
-          </a:fillRef>
-          <a:effectRef idx="2">
-            <a:schemeClr val="accent1"/>
-          </a:effectRef>
-          <a:fontRef idx="minor">
-            <a:schemeClr val="lt1"/>
-          </a:fontRef>
-        </p:style>
-        <p:txBody>
-          <a:bodyPr rtlCol="0" anchor="ctr"/>
-          <a:lstStyle/>
-          <a:p>
-            <a:pPr algn="ctr"/>
-          </a:p>
-        </p:txBody>
-      </p:sp>
       <p:pic>
         <p:nvPicPr>
-          <p:cNvPr id="4" name="Picture 3" descr="salescore_logo.png"/>
+          <p:cNvPr id="3" name="Picture 2" descr="salescore_logo_white.png"/>
           <p:cNvPicPr>
             <a:picLocks noChangeAspect="1"/>
           </p:cNvPicPr>
@@ -3192,14 +3149,57 @@
         </p:blipFill>
         <p:spPr>
           <a:xfrm>
-            <a:off x="9875520" y="73152"/>
-            <a:ext cx="1920240" cy="566928"/>
+            <a:off x="411480" y="384048"/>
+            <a:ext cx="1645920" cy="457200"/>
           </a:xfrm>
           <a:prstGeom prst="rect">
             <a:avLst/>
           </a:prstGeom>
         </p:spPr>
       </p:pic>
+      <p:sp>
+        <p:nvSpPr>
+          <p:cNvPr id="4" name="Rectangle 3"/>
+          <p:cNvSpPr/>
+          <p:nvPr/>
+        </p:nvSpPr>
+        <p:spPr>
+          <a:xfrm>
+            <a:off x="411480" y="1005840"/>
+            <a:ext cx="3383280" cy="19050"/>
+          </a:xfrm>
+          <a:prstGeom prst="rect">
+            <a:avLst/>
+          </a:prstGeom>
+          <a:solidFill>
+            <a:srgbClr val="2563EB"/>
+          </a:solidFill>
+          <a:ln>
+            <a:noFill/>
+          </a:ln>
+        </p:spPr>
+        <p:style>
+          <a:lnRef idx="1">
+            <a:schemeClr val="accent1"/>
+          </a:lnRef>
+          <a:fillRef idx="3">
+            <a:schemeClr val="accent1"/>
+          </a:fillRef>
+          <a:effectRef idx="2">
+            <a:schemeClr val="accent1"/>
+          </a:effectRef>
+          <a:fontRef idx="minor">
+            <a:schemeClr val="lt1"/>
+          </a:fontRef>
+        </p:style>
+        <p:txBody>
+          <a:bodyPr rtlCol="0" anchor="ctr"/>
+          <a:lstStyle/>
+          <a:p>
+            <a:pPr algn="ctr"/>
+          </a:p>
+        </p:txBody>
+      </p:sp>
       <p:sp>
         <p:nvSpPr>
           <p:cNvPr id="5" name="TextBox 4"/>
@@ -3208,8 +3208,8 @@
         </p:nvSpPr>
         <p:spPr>
           <a:xfrm>
-            <a:off x="1097280" y="1371600"/>
-            <a:ext cx="7315200" cy="640080"/>
+            <a:off x="411480" y="1115568"/>
+            <a:ext cx="3474720" cy="457200"/>
           </a:xfrm>
           <a:prstGeom prst="rect">
             <a:avLst/>
@@ -3224,13 +3224,13 @@
           <a:p>
             <a:pPr algn="l"/>
             <a:r>
-              <a:rPr sz="1800" b="0">
-                <a:solidFill>
-                  <a:srgbClr val="000000"/>
-                </a:solidFill>
-                <a:latin typeface="Noto Sans JP"/>
+              <a:rPr sz="1200" b="0" i="0">
+                <a:solidFill>
+                  <a:srgbClr val="FFFFFF"/>
+                </a:solidFill>
+                <a:latin typeface="IPAGothic"/>
               </a:rPr>
-              <a:t>株式会社〇〇  御中</a:t>
+              <a:t>SALESCORE株式会社</a:t>
             </a:r>
           </a:p>
         </p:txBody>
@@ -3243,8 +3243,8 @@
         </p:nvSpPr>
         <p:spPr>
           <a:xfrm>
-            <a:off x="1097280" y="2286000"/>
-            <a:ext cx="9144000" cy="1828800"/>
+            <a:off x="411480" y="5943600"/>
+            <a:ext cx="2743200" cy="365760"/>
           </a:xfrm>
           <a:prstGeom prst="rect">
             <a:avLst/>
@@ -3259,11 +3259,202 @@
           <a:p>
             <a:pPr algn="l"/>
             <a:r>
-              <a:rPr sz="4000" b="1">
-                <a:solidFill>
-                  <a:srgbClr val="000000"/>
-                </a:solidFill>
-                <a:latin typeface="Noto Sans JP"/>
+              <a:rPr sz="1100" b="0" i="0">
+                <a:solidFill>
+                  <a:srgbClr val="94A3B8"/>
+                </a:solidFill>
+                <a:latin typeface="IPAGothic"/>
+              </a:rPr>
+              <a:t>2026年3月</a:t>
+            </a:r>
+          </a:p>
+        </p:txBody>
+      </p:sp>
+      <p:sp>
+        <p:nvSpPr>
+          <p:cNvPr id="7" name="TextBox 6"/>
+          <p:cNvSpPr txBox="1"/>
+          <p:nvPr/>
+        </p:nvSpPr>
+        <p:spPr>
+          <a:xfrm>
+            <a:off x="411480" y="6400800"/>
+            <a:ext cx="2743200" cy="320040"/>
+          </a:xfrm>
+          <a:prstGeom prst="rect">
+            <a:avLst/>
+          </a:prstGeom>
+          <a:noFill/>
+        </p:spPr>
+        <p:txBody>
+          <a:bodyPr wrap="square">
+            <a:spAutoFit/>
+          </a:bodyPr>
+          <a:lstStyle/>
+          <a:p>
+            <a:pPr algn="l"/>
+            <a:r>
+              <a:rPr sz="800" b="0" i="0">
+                <a:solidFill>
+                  <a:srgbClr val="94A3B8"/>
+                </a:solidFill>
+                <a:latin typeface="Calibri"/>
+              </a:rPr>
+              <a:t>Confidential</a:t>
+            </a:r>
+          </a:p>
+        </p:txBody>
+      </p:sp>
+      <p:sp>
+        <p:nvSpPr>
+          <p:cNvPr id="8" name="Rectangle 7"/>
+          <p:cNvSpPr/>
+          <p:nvPr/>
+        </p:nvSpPr>
+        <p:spPr>
+          <a:xfrm>
+            <a:off x="4206240" y="0"/>
+            <a:ext cx="54864" cy="6858000"/>
+          </a:xfrm>
+          <a:prstGeom prst="rect">
+            <a:avLst/>
+          </a:prstGeom>
+          <a:solidFill>
+            <a:srgbClr val="2563EB"/>
+          </a:solidFill>
+          <a:ln>
+            <a:noFill/>
+          </a:ln>
+        </p:spPr>
+        <p:style>
+          <a:lnRef idx="1">
+            <a:schemeClr val="accent1"/>
+          </a:lnRef>
+          <a:fillRef idx="3">
+            <a:schemeClr val="accent1"/>
+          </a:fillRef>
+          <a:effectRef idx="2">
+            <a:schemeClr val="accent1"/>
+          </a:effectRef>
+          <a:fontRef idx="minor">
+            <a:schemeClr val="lt1"/>
+          </a:fontRef>
+        </p:style>
+        <p:txBody>
+          <a:bodyPr rtlCol="0" anchor="ctr"/>
+          <a:lstStyle/>
+          <a:p>
+            <a:pPr algn="ctr"/>
+          </a:p>
+        </p:txBody>
+      </p:sp>
+      <p:sp>
+        <p:nvSpPr>
+          <p:cNvPr id="9" name="TextBox 8"/>
+          <p:cNvSpPr txBox="1"/>
+          <p:nvPr/>
+        </p:nvSpPr>
+        <p:spPr>
+          <a:xfrm>
+            <a:off x="5029200" y="1371600"/>
+            <a:ext cx="6858000" cy="502920"/>
+          </a:xfrm>
+          <a:prstGeom prst="rect">
+            <a:avLst/>
+          </a:prstGeom>
+          <a:noFill/>
+        </p:spPr>
+        <p:txBody>
+          <a:bodyPr wrap="square">
+            <a:spAutoFit/>
+          </a:bodyPr>
+          <a:lstStyle/>
+          <a:p>
+            <a:pPr algn="l"/>
+            <a:r>
+              <a:rPr sz="1600" b="0" i="0">
+                <a:solidFill>
+                  <a:srgbClr val="475569"/>
+                </a:solidFill>
+                <a:latin typeface="IPAGothic"/>
+              </a:rPr>
+              <a:t>株式会社〇〇  御中</a:t>
+            </a:r>
+          </a:p>
+        </p:txBody>
+      </p:sp>
+      <p:sp>
+        <p:nvSpPr>
+          <p:cNvPr id="10" name="Rectangle 9"/>
+          <p:cNvSpPr/>
+          <p:nvPr/>
+        </p:nvSpPr>
+        <p:spPr>
+          <a:xfrm>
+            <a:off x="5029200" y="1993392"/>
+            <a:ext cx="6858000" cy="38100"/>
+          </a:xfrm>
+          <a:prstGeom prst="rect">
+            <a:avLst/>
+          </a:prstGeom>
+          <a:solidFill>
+            <a:srgbClr val="1E3A8A"/>
+          </a:solidFill>
+          <a:ln>
+            <a:noFill/>
+          </a:ln>
+        </p:spPr>
+        <p:style>
+          <a:lnRef idx="1">
+            <a:schemeClr val="accent1"/>
+          </a:lnRef>
+          <a:fillRef idx="3">
+            <a:schemeClr val="accent1"/>
+          </a:fillRef>
+          <a:effectRef idx="2">
+            <a:schemeClr val="accent1"/>
+          </a:effectRef>
+          <a:fontRef idx="minor">
+            <a:schemeClr val="lt1"/>
+          </a:fontRef>
+        </p:style>
+        <p:txBody>
+          <a:bodyPr rtlCol="0" anchor="ctr"/>
+          <a:lstStyle/>
+          <a:p>
+            <a:pPr algn="ctr"/>
+          </a:p>
+        </p:txBody>
+      </p:sp>
+      <p:sp>
+        <p:nvSpPr>
+          <p:cNvPr id="11" name="TextBox 10"/>
+          <p:cNvSpPr txBox="1"/>
+          <p:nvPr/>
+        </p:nvSpPr>
+        <p:spPr>
+          <a:xfrm>
+            <a:off x="5029200" y="2121408"/>
+            <a:ext cx="6858000" cy="2377440"/>
+          </a:xfrm>
+          <a:prstGeom prst="rect">
+            <a:avLst/>
+          </a:prstGeom>
+          <a:noFill/>
+        </p:spPr>
+        <p:txBody>
+          <a:bodyPr wrap="square">
+            <a:spAutoFit/>
+          </a:bodyPr>
+          <a:lstStyle/>
+          <a:p>
+            <a:pPr algn="l"/>
+            <a:r>
+              <a:rPr sz="3800" b="1" i="0">
+                <a:solidFill>
+                  <a:srgbClr val="0F172A"/>
+                </a:solidFill>
+                <a:latin typeface="IPAGothic"/>
               </a:rPr>
               <a:t>営業生産性を2倍にする
 3つのアクション</a:t>
@@ -3273,14 +3464,57 @@
       </p:sp>
       <p:sp>
         <p:nvSpPr>
-          <p:cNvPr id="7" name="TextBox 6"/>
+          <p:cNvPr id="12" name="Rectangle 11"/>
+          <p:cNvSpPr/>
+          <p:nvPr/>
+        </p:nvSpPr>
+        <p:spPr>
+          <a:xfrm>
+            <a:off x="5029200" y="4681728"/>
+            <a:ext cx="6858000" cy="19050"/>
+          </a:xfrm>
+          <a:prstGeom prst="rect">
+            <a:avLst/>
+          </a:prstGeom>
+          <a:solidFill>
+            <a:srgbClr val="CBD5E1"/>
+          </a:solidFill>
+          <a:ln>
+            <a:noFill/>
+          </a:ln>
+        </p:spPr>
+        <p:style>
+          <a:lnRef idx="1">
+            <a:schemeClr val="accent1"/>
+          </a:lnRef>
+          <a:fillRef idx="3">
+            <a:schemeClr val="accent1"/>
+          </a:fillRef>
+          <a:effectRef idx="2">
+            <a:schemeClr val="accent1"/>
+          </a:effectRef>
+          <a:fontRef idx="minor">
+            <a:schemeClr val="lt1"/>
+          </a:fontRef>
+        </p:style>
+        <p:txBody>
+          <a:bodyPr rtlCol="0" anchor="ctr"/>
+          <a:lstStyle/>
+          <a:p>
+            <a:pPr algn="ctr"/>
+          </a:p>
+        </p:txBody>
+      </p:sp>
+      <p:sp>
+        <p:nvSpPr>
+          <p:cNvPr id="13" name="TextBox 12"/>
           <p:cNvSpPr txBox="1"/>
           <p:nvPr/>
         </p:nvSpPr>
         <p:spPr>
           <a:xfrm>
-            <a:off x="1097280" y="4754880"/>
-            <a:ext cx="5486400" cy="548640"/>
+            <a:off x="5029200" y="4773168"/>
+            <a:ext cx="6858000" cy="457200"/>
           </a:xfrm>
           <a:prstGeom prst="rect">
             <a:avLst/>
@@ -3295,83 +3529,13 @@
           <a:p>
             <a:pPr algn="l"/>
             <a:r>
-              <a:rPr sz="1600" b="0">
-                <a:solidFill>
-                  <a:srgbClr val="000000"/>
-                </a:solidFill>
-                <a:latin typeface="Noto Sans JP"/>
+              <a:rPr sz="1300" b="0" i="1">
+                <a:solidFill>
+                  <a:srgbClr val="475569"/>
+                </a:solidFill>
+                <a:latin typeface="IPAGothic"/>
               </a:rPr>
-              <a:t>SALESCORE株式会社</a:t>
-            </a:r>
-          </a:p>
-        </p:txBody>
-      </p:sp>
-      <p:sp>
-        <p:nvSpPr>
-          <p:cNvPr id="8" name="TextBox 7"/>
-          <p:cNvSpPr txBox="1"/>
-          <p:nvPr/>
-        </p:nvSpPr>
-        <p:spPr>
-          <a:xfrm>
-            <a:off x="365760" y="6446520"/>
-            <a:ext cx="9144000" cy="320040"/>
-          </a:xfrm>
-          <a:prstGeom prst="rect">
-            <a:avLst/>
-          </a:prstGeom>
-          <a:noFill/>
-        </p:spPr>
-        <p:txBody>
-          <a:bodyPr wrap="square">
-            <a:spAutoFit/>
-          </a:bodyPr>
-          <a:lstStyle/>
-          <a:p>
-            <a:pPr algn="l"/>
-            <a:r>
-              <a:rPr sz="800" b="0">
-                <a:solidFill>
-                  <a:srgbClr val="9CA3AF"/>
-                </a:solidFill>
-                <a:latin typeface="Noto Sans JP"/>
-              </a:rPr>
-              <a:t>Confidential All Rights Reserved SALESCORE Inc.</a:t>
-            </a:r>
-          </a:p>
-        </p:txBody>
-      </p:sp>
-      <p:sp>
-        <p:nvSpPr>
-          <p:cNvPr id="9" name="TextBox 8"/>
-          <p:cNvSpPr txBox="1"/>
-          <p:nvPr/>
-        </p:nvSpPr>
-        <p:spPr>
-          <a:xfrm>
-            <a:off x="11430000" y="6446520"/>
-            <a:ext cx="365760" cy="320040"/>
-          </a:xfrm>
-          <a:prstGeom prst="rect">
-            <a:avLst/>
-          </a:prstGeom>
-          <a:noFill/>
-        </p:spPr>
-        <p:txBody>
-          <a:bodyPr wrap="square">
-            <a:spAutoFit/>
-          </a:bodyPr>
-          <a:lstStyle/>
-          <a:p>
-            <a:pPr algn="r"/>
-            <a:r>
-              <a:rPr sz="1000" b="0">
-                <a:solidFill>
-                  <a:srgbClr val="000000"/>
-                </a:solidFill>
-                <a:latin typeface="Noto Sans JP"/>
-              </a:rPr>
-              <a:t>1</a:t>
+              <a:t>データ活用 × 行動変容 × 組織定着</a:t>
             </a:r>
           </a:p>
         </p:txBody>
@@ -3394,87 +3558,9 @@
         <p:nvPr/>
       </p:nvGrpSpPr>
       <p:grpSpPr/>
-      <p:sp>
-        <p:nvSpPr>
-          <p:cNvPr id="2" name="Rectangle 1"/>
-          <p:cNvSpPr/>
-          <p:nvPr/>
-        </p:nvSpPr>
-        <p:spPr>
-          <a:xfrm>
-            <a:off x="365760" y="685800"/>
-            <a:ext cx="11430000" cy="19050"/>
-          </a:xfrm>
-          <a:prstGeom prst="rect">
-            <a:avLst/>
-          </a:prstGeom>
-          <a:solidFill>
-            <a:srgbClr val="000000"/>
-          </a:solidFill>
-          <a:ln>
-            <a:noFill/>
-          </a:ln>
-        </p:spPr>
-        <p:style>
-          <a:lnRef idx="1">
-            <a:schemeClr val="accent1"/>
-          </a:lnRef>
-          <a:fillRef idx="3">
-            <a:schemeClr val="accent1"/>
-          </a:fillRef>
-          <a:effectRef idx="2">
-            <a:schemeClr val="accent1"/>
-          </a:effectRef>
-          <a:fontRef idx="minor">
-            <a:schemeClr val="lt1"/>
-          </a:fontRef>
-        </p:style>
-        <p:txBody>
-          <a:bodyPr rtlCol="0" anchor="ctr"/>
-          <a:lstStyle/>
-          <a:p>
-            <a:pPr algn="ctr"/>
-          </a:p>
-        </p:txBody>
-      </p:sp>
-      <p:sp>
-        <p:nvSpPr>
-          <p:cNvPr id="3" name="TextBox 2"/>
-          <p:cNvSpPr txBox="1"/>
-          <p:nvPr/>
-        </p:nvSpPr>
-        <p:spPr>
-          <a:xfrm>
-            <a:off x="365760" y="137160"/>
-            <a:ext cx="7315200" cy="548640"/>
-          </a:xfrm>
-          <a:prstGeom prst="rect">
-            <a:avLst/>
-          </a:prstGeom>
-          <a:noFill/>
-        </p:spPr>
-        <p:txBody>
-          <a:bodyPr wrap="square">
-            <a:spAutoFit/>
-          </a:bodyPr>
-          <a:lstStyle/>
-          <a:p>
-            <a:pPr algn="l"/>
-            <a:r>
-              <a:rPr sz="1800" b="1">
-                <a:solidFill>
-                  <a:srgbClr val="000000"/>
-                </a:solidFill>
-                <a:latin typeface="Noto Sans JP"/>
-              </a:rPr>
-              <a:t>売上の8割を2割の「できる営業」が担う構造が、組織スケールを阻んでいる</a:t>
-            </a:r>
-          </a:p>
-        </p:txBody>
-      </p:sp>
       <p:pic>
         <p:nvPicPr>
-          <p:cNvPr id="4" name="Picture 3" descr="salescore_logo.png"/>
+          <p:cNvPr id="2" name="Picture 1" descr="salescore_logo.png"/>
           <p:cNvPicPr>
             <a:picLocks noChangeAspect="1"/>
           </p:cNvPicPr>
@@ -3488,8 +3574,8 @@
         </p:blipFill>
         <p:spPr>
           <a:xfrm>
-            <a:off x="9875520" y="73152"/>
-            <a:ext cx="1920240" cy="566928"/>
+            <a:off x="9948672" y="164592"/>
+            <a:ext cx="1737360" cy="475488"/>
           </a:xfrm>
           <a:prstGeom prst="rect">
             <a:avLst/>
@@ -3498,20 +3584,55 @@
       </p:pic>
       <p:sp>
         <p:nvSpPr>
-          <p:cNvPr id="5" name="Rectangle 4"/>
+          <p:cNvPr id="3" name="TextBox 2"/>
+          <p:cNvSpPr txBox="1"/>
+          <p:nvPr/>
+        </p:nvSpPr>
+        <p:spPr>
+          <a:xfrm>
+            <a:off x="594360" y="182880"/>
+            <a:ext cx="8961120" cy="548640"/>
+          </a:xfrm>
+          <a:prstGeom prst="rect">
+            <a:avLst/>
+          </a:prstGeom>
+          <a:noFill/>
+        </p:spPr>
+        <p:txBody>
+          <a:bodyPr wrap="square">
+            <a:spAutoFit/>
+          </a:bodyPr>
+          <a:lstStyle/>
+          <a:p>
+            <a:pPr algn="l"/>
+            <a:r>
+              <a:rPr sz="2000" b="1" i="0">
+                <a:solidFill>
+                  <a:srgbClr val="0F172A"/>
+                </a:solidFill>
+                <a:latin typeface="IPAGothic"/>
+              </a:rPr>
+              <a:t>売上の8割を2割の「できる営業」が担う構造が、組織スケールを阻んでいる</a:t>
+            </a:r>
+          </a:p>
+        </p:txBody>
+      </p:sp>
+      <p:sp>
+        <p:nvSpPr>
+          <p:cNvPr id="4" name="Rectangle 3"/>
           <p:cNvSpPr/>
           <p:nvPr/>
         </p:nvSpPr>
         <p:spPr>
           <a:xfrm>
-            <a:off x="365760" y="6400800"/>
-            <a:ext cx="11430000" cy="19050"/>
+            <a:off x="594360" y="749808"/>
+            <a:ext cx="11000232" cy="31750"/>
           </a:xfrm>
           <a:prstGeom prst="rect">
             <a:avLst/>
           </a:prstGeom>
           <a:solidFill>
-            <a:srgbClr val="000000"/>
+            <a:srgbClr val="1E3A8A"/>
           </a:solidFill>
           <a:ln>
             <a:noFill/>
@@ -3541,90 +3662,20 @@
       </p:sp>
       <p:sp>
         <p:nvSpPr>
-          <p:cNvPr id="6" name="TextBox 5"/>
-          <p:cNvSpPr txBox="1"/>
-          <p:nvPr/>
-        </p:nvSpPr>
-        <p:spPr>
-          <a:xfrm>
-            <a:off x="365760" y="6446520"/>
-            <a:ext cx="9144000" cy="320040"/>
-          </a:xfrm>
-          <a:prstGeom prst="rect">
-            <a:avLst/>
-          </a:prstGeom>
-          <a:noFill/>
-        </p:spPr>
-        <p:txBody>
-          <a:bodyPr wrap="square">
-            <a:spAutoFit/>
-          </a:bodyPr>
-          <a:lstStyle/>
-          <a:p>
-            <a:pPr algn="l"/>
-            <a:r>
-              <a:rPr sz="800" b="0">
-                <a:solidFill>
-                  <a:srgbClr val="9CA3AF"/>
-                </a:solidFill>
-                <a:latin typeface="Noto Sans JP"/>
-              </a:rPr>
-              <a:t>Confidential All Rights Reserved SALESCORE Inc.</a:t>
-            </a:r>
-          </a:p>
-        </p:txBody>
-      </p:sp>
-      <p:sp>
-        <p:nvSpPr>
-          <p:cNvPr id="7" name="TextBox 6"/>
-          <p:cNvSpPr txBox="1"/>
-          <p:nvPr/>
-        </p:nvSpPr>
-        <p:spPr>
-          <a:xfrm>
-            <a:off x="11430000" y="6446520"/>
-            <a:ext cx="365760" cy="320040"/>
-          </a:xfrm>
-          <a:prstGeom prst="rect">
-            <a:avLst/>
-          </a:prstGeom>
-          <a:noFill/>
-        </p:spPr>
-        <p:txBody>
-          <a:bodyPr wrap="square">
-            <a:spAutoFit/>
-          </a:bodyPr>
-          <a:lstStyle/>
-          <a:p>
-            <a:pPr algn="r"/>
-            <a:r>
-              <a:rPr sz="1000" b="0">
-                <a:solidFill>
-                  <a:srgbClr val="000000"/>
-                </a:solidFill>
-                <a:latin typeface="Noto Sans JP"/>
-              </a:rPr>
-              <a:t>2</a:t>
-            </a:r>
-          </a:p>
-        </p:txBody>
-      </p:sp>
-      <p:sp>
-        <p:nvSpPr>
-          <p:cNvPr id="8" name="Rectangle 7"/>
+          <p:cNvPr id="5" name="Rectangle 4"/>
           <p:cNvSpPr/>
           <p:nvPr/>
         </p:nvSpPr>
         <p:spPr>
           <a:xfrm>
-            <a:off x="365760" y="822960"/>
-            <a:ext cx="11430000" cy="411480"/>
+            <a:off x="594360" y="6327648"/>
+            <a:ext cx="11000232" cy="12700"/>
           </a:xfrm>
           <a:prstGeom prst="rect">
             <a:avLst/>
           </a:prstGeom>
           <a:solidFill>
-            <a:srgbClr val="374151"/>
+            <a:srgbClr val="CBD5E1"/>
           </a:solidFill>
           <a:ln>
             <a:noFill/>
@@ -3645,31 +3696,23 @@
           </a:fontRef>
         </p:style>
         <p:txBody>
-          <a:bodyPr rtlCol="0" anchor="ctr" wrap="square"/>
-          <a:lstStyle/>
-          <a:p>
-            <a:pPr algn="l"/>
-            <a:r>
-              <a:rPr sz="1200" b="1">
-                <a:solidFill>
-                  <a:srgbClr val="FFFFFF"/>
-                </a:solidFill>
-              </a:rPr>
-              <a:t>日本の営業組織が抱える構造的課題</a:t>
-            </a:r>
-          </a:p>
-        </p:txBody>
-      </p:sp>
-      <p:sp>
-        <p:nvSpPr>
-          <p:cNvPr id="9" name="TextBox 8"/>
+          <a:bodyPr rtlCol="0" anchor="ctr"/>
+          <a:lstStyle/>
+          <a:p>
+            <a:pPr algn="ctr"/>
+          </a:p>
+        </p:txBody>
+      </p:sp>
+      <p:sp>
+        <p:nvSpPr>
+          <p:cNvPr id="6" name="TextBox 5"/>
           <p:cNvSpPr txBox="1"/>
           <p:nvPr/>
         </p:nvSpPr>
         <p:spPr>
           <a:xfrm>
-            <a:off x="365760" y="1325880"/>
-            <a:ext cx="11430000" cy="365760"/>
+            <a:off x="594360" y="6373368"/>
+            <a:ext cx="8686800" cy="320040"/>
           </a:xfrm>
           <a:prstGeom prst="rect">
             <a:avLst/>
@@ -3684,11 +3727,81 @@
           <a:p>
             <a:pPr algn="l"/>
             <a:r>
-              <a:rPr sz="1200" b="0">
-                <a:solidFill>
-                  <a:srgbClr val="000000"/>
-                </a:solidFill>
-                <a:latin typeface="Noto Sans JP"/>
+              <a:rPr sz="800" b="0" i="0">
+                <a:solidFill>
+                  <a:srgbClr val="94A3B8"/>
+                </a:solidFill>
+                <a:latin typeface="Calibri"/>
+              </a:rPr>
+              <a:t>Confidential  All Rights Reserved SALESCORE Inc.</a:t>
+            </a:r>
+          </a:p>
+        </p:txBody>
+      </p:sp>
+      <p:sp>
+        <p:nvSpPr>
+          <p:cNvPr id="7" name="TextBox 6"/>
+          <p:cNvSpPr txBox="1"/>
+          <p:nvPr/>
+        </p:nvSpPr>
+        <p:spPr>
+          <a:xfrm>
+            <a:off x="11430000" y="6373368"/>
+            <a:ext cx="457200" cy="320040"/>
+          </a:xfrm>
+          <a:prstGeom prst="rect">
+            <a:avLst/>
+          </a:prstGeom>
+          <a:noFill/>
+        </p:spPr>
+        <p:txBody>
+          <a:bodyPr wrap="square">
+            <a:spAutoFit/>
+          </a:bodyPr>
+          <a:lstStyle/>
+          <a:p>
+            <a:pPr algn="r"/>
+            <a:r>
+              <a:rPr sz="900" b="0" i="0">
+                <a:solidFill>
+                  <a:srgbClr val="94A3B8"/>
+                </a:solidFill>
+                <a:latin typeface="Calibri"/>
+              </a:rPr>
+              <a:t>2</a:t>
+            </a:r>
+          </a:p>
+        </p:txBody>
+      </p:sp>
+      <p:sp>
+        <p:nvSpPr>
+          <p:cNvPr id="8" name="TextBox 7"/>
+          <p:cNvSpPr txBox="1"/>
+          <p:nvPr/>
+        </p:nvSpPr>
+        <p:spPr>
+          <a:xfrm>
+            <a:off x="594360" y="960120"/>
+            <a:ext cx="9601200" cy="365760"/>
+          </a:xfrm>
+          <a:prstGeom prst="rect">
+            <a:avLst/>
+          </a:prstGeom>
+          <a:noFill/>
+        </p:spPr>
+        <p:txBody>
+          <a:bodyPr wrap="square">
+            <a:spAutoFit/>
+          </a:bodyPr>
+          <a:lstStyle/>
+          <a:p>
+            <a:pPr algn="l"/>
+            <a:r>
+              <a:rPr sz="1100" b="0" i="0">
+                <a:solidFill>
+                  <a:srgbClr val="475569"/>
+                </a:solidFill>
+                <a:latin typeface="IPAGothic"/>
               </a:rPr>
               <a:t>売上の78%をトップ20%の営業が創出。属人化が組織の成長を制約している。</a:t>
             </a:r>
@@ -3697,20 +3810,20 @@
       </p:sp>
       <p:sp>
         <p:nvSpPr>
-          <p:cNvPr id="10" name="Rectangle 9"/>
+          <p:cNvPr id="9" name="Rectangle 8"/>
           <p:cNvSpPr/>
           <p:nvPr/>
         </p:nvSpPr>
         <p:spPr>
           <a:xfrm>
-            <a:off x="365760" y="1828800"/>
-            <a:ext cx="5303520" cy="365760"/>
+            <a:off x="594360" y="1417320"/>
+            <a:ext cx="5120640" cy="384048"/>
           </a:xfrm>
           <a:prstGeom prst="rect">
             <a:avLst/>
           </a:prstGeom>
           <a:solidFill>
-            <a:srgbClr val="1E3A6E"/>
+            <a:srgbClr val="1E3A8A"/>
           </a:solidFill>
           <a:ln>
             <a:noFill/>
@@ -3734,14 +3847,50 @@
           <a:bodyPr rtlCol="0" anchor="ctr" wrap="square"/>
           <a:lstStyle/>
           <a:p>
-            <a:pPr algn="ctr"/>
-            <a:r>
-              <a:rPr sz="1200" b="1">
+            <a:pPr algn="l"/>
+            <a:r>
+              <a:rPr sz="1100" b="1">
                 <a:solidFill>
                   <a:srgbClr val="FFFFFF"/>
                 </a:solidFill>
+                <a:latin typeface="IPAGothic"/>
               </a:rPr>
-              <a:t>属人化が生む3つの弊害</a:t>
+              <a:t>属人化が生む 3 つの弊害</a:t>
+            </a:r>
+          </a:p>
+        </p:txBody>
+      </p:sp>
+      <p:sp>
+        <p:nvSpPr>
+          <p:cNvPr id="10" name="TextBox 9"/>
+          <p:cNvSpPr txBox="1"/>
+          <p:nvPr/>
+        </p:nvSpPr>
+        <p:spPr>
+          <a:xfrm>
+            <a:off x="777240" y="1472184"/>
+            <a:ext cx="4846320" cy="292608"/>
+          </a:xfrm>
+          <a:prstGeom prst="rect">
+            <a:avLst/>
+          </a:prstGeom>
+          <a:noFill/>
+        </p:spPr>
+        <p:txBody>
+          <a:bodyPr wrap="square">
+            <a:spAutoFit/>
+          </a:bodyPr>
+          <a:lstStyle/>
+          <a:p>
+            <a:pPr algn="l"/>
+            <a:r>
+              <a:rPr sz="1100" b="1" i="0">
+                <a:solidFill>
+                  <a:srgbClr val="FFFFFF"/>
+                </a:solidFill>
+                <a:latin typeface="IPAGothic"/>
+              </a:rPr>
+              <a:t>属人化が生む 3 つの弊害</a:t>
             </a:r>
           </a:p>
         </p:txBody>
@@ -3754,18 +3903,18 @@
         </p:nvSpPr>
         <p:spPr>
           <a:xfrm>
-            <a:off x="365760" y="2286000"/>
-            <a:ext cx="5303520" cy="1005840"/>
+            <a:off x="594360" y="1892808"/>
+            <a:ext cx="5120640" cy="1389888"/>
           </a:xfrm>
           <a:prstGeom prst="rect">
             <a:avLst/>
           </a:prstGeom>
           <a:solidFill>
-            <a:srgbClr val="DBEAF8"/>
+            <a:srgbClr val="EFF4FF"/>
           </a:solidFill>
-          <a:ln w="19050">
+          <a:ln w="15240">
             <a:solidFill>
-              <a:srgbClr val="275BC4"/>
+              <a:srgbClr val="DBEAFE"/>
             </a:solidFill>
           </a:ln>
         </p:spPr>
@@ -3799,14 +3948,14 @@
         </p:nvSpPr>
         <p:spPr>
           <a:xfrm>
-            <a:off x="457200" y="2468880"/>
-            <a:ext cx="411480" cy="411480"/>
+            <a:off x="758952" y="2057400"/>
+            <a:ext cx="420624" cy="420624"/>
           </a:xfrm>
           <a:prstGeom prst="rect">
             <a:avLst/>
           </a:prstGeom>
           <a:solidFill>
-            <a:srgbClr val="1E3A6E"/>
+            <a:srgbClr val="1E3A8A"/>
           </a:solidFill>
           <a:ln>
             <a:noFill/>
@@ -3836,8 +3985,9 @@
                 <a:solidFill>
                   <a:srgbClr val="FFFFFF"/>
                 </a:solidFill>
+                <a:latin typeface="Calibri"/>
               </a:rPr>
-              <a:t>❶</a:t>
+              <a:t>01</a:t>
             </a:r>
           </a:p>
         </p:txBody>
@@ -3850,8 +4000,8 @@
         </p:nvSpPr>
         <p:spPr>
           <a:xfrm>
-            <a:off x="1005840" y="2377440"/>
-            <a:ext cx="4572000" cy="822960"/>
+            <a:off x="1307592" y="2020824"/>
+            <a:ext cx="4297680" cy="347472"/>
           </a:xfrm>
           <a:prstGeom prst="rect">
             <a:avLst/>
@@ -3866,38 +4016,73 @@
           <a:p>
             <a:pPr algn="l"/>
             <a:r>
-              <a:rPr sz="1200" b="0">
-                <a:solidFill>
-                  <a:srgbClr val="000000"/>
-                </a:solidFill>
-                <a:latin typeface="Noto Sans JP"/>
+              <a:rPr sz="1200" b="1" i="0">
+                <a:solidFill>
+                  <a:srgbClr val="0F172A"/>
+                </a:solidFill>
+                <a:latin typeface="IPAGothic"/>
               </a:rPr>
-              <a:t>育成が属人的で
-ノウハウが継承されない</a:t>
-            </a:r>
-          </a:p>
-        </p:txBody>
-      </p:sp>
-      <p:sp>
-        <p:nvSpPr>
-          <p:cNvPr id="14" name="Rectangle 13"/>
+              <a:t>育成が属人的でノウハウが継承されない</a:t>
+            </a:r>
+          </a:p>
+        </p:txBody>
+      </p:sp>
+      <p:sp>
+        <p:nvSpPr>
+          <p:cNvPr id="14" name="TextBox 13"/>
+          <p:cNvSpPr txBox="1"/>
+          <p:nvPr/>
+        </p:nvSpPr>
+        <p:spPr>
+          <a:xfrm>
+            <a:off x="1307592" y="2368296"/>
+            <a:ext cx="4297680" cy="841248"/>
+          </a:xfrm>
+          <a:prstGeom prst="rect">
+            <a:avLst/>
+          </a:prstGeom>
+          <a:noFill/>
+        </p:spPr>
+        <p:txBody>
+          <a:bodyPr wrap="square">
+            <a:spAutoFit/>
+          </a:bodyPr>
+          <a:lstStyle/>
+          <a:p>
+            <a:pPr algn="l"/>
+            <a:r>
+              <a:rPr sz="950" b="0" i="0">
+                <a:solidFill>
+                  <a:srgbClr val="475569"/>
+                </a:solidFill>
+                <a:latin typeface="IPAGothic"/>
+              </a:rPr>
+              <a:t>トップ営業の知識・経験が組織内に蓄積されず、
+離職や異動のたびにノウハウがリセットされる。</a:t>
+            </a:r>
+          </a:p>
+        </p:txBody>
+      </p:sp>
+      <p:sp>
+        <p:nvSpPr>
+          <p:cNvPr id="15" name="Rectangle 14"/>
           <p:cNvSpPr/>
           <p:nvPr/>
         </p:nvSpPr>
         <p:spPr>
           <a:xfrm>
-            <a:off x="365760" y="3474720"/>
-            <a:ext cx="5303520" cy="1005840"/>
+            <a:off x="594360" y="3401568"/>
+            <a:ext cx="5120640" cy="1389888"/>
           </a:xfrm>
           <a:prstGeom prst="rect">
             <a:avLst/>
           </a:prstGeom>
           <a:solidFill>
-            <a:srgbClr val="DBEAF8"/>
+            <a:srgbClr val="EFF4FF"/>
           </a:solidFill>
-          <a:ln w="19050">
+          <a:ln w="15240">
             <a:solidFill>
-              <a:srgbClr val="275BC4"/>
+              <a:srgbClr val="DBEAFE"/>
             </a:solidFill>
           </a:ln>
         </p:spPr>
@@ -3925,20 +4110,20 @@
       </p:sp>
       <p:sp>
         <p:nvSpPr>
-          <p:cNvPr id="15" name="Rectangle 14"/>
+          <p:cNvPr id="16" name="Rectangle 15"/>
           <p:cNvSpPr/>
           <p:nvPr/>
         </p:nvSpPr>
         <p:spPr>
           <a:xfrm>
-            <a:off x="457200" y="3657600"/>
-            <a:ext cx="411480" cy="411480"/>
+            <a:off x="758952" y="3566160"/>
+            <a:ext cx="420624" cy="420624"/>
           </a:xfrm>
           <a:prstGeom prst="rect">
             <a:avLst/>
           </a:prstGeom>
           <a:solidFill>
-            <a:srgbClr val="1E3A6E"/>
+            <a:srgbClr val="1E3A8A"/>
           </a:solidFill>
           <a:ln>
             <a:noFill/>
@@ -3968,22 +4153,23 @@
                 <a:solidFill>
                   <a:srgbClr val="FFFFFF"/>
                 </a:solidFill>
+                <a:latin typeface="Calibri"/>
               </a:rPr>
-              <a:t>❷</a:t>
-            </a:r>
-          </a:p>
-        </p:txBody>
-      </p:sp>
-      <p:sp>
-        <p:nvSpPr>
-          <p:cNvPr id="16" name="TextBox 15"/>
+              <a:t>02</a:t>
+            </a:r>
+          </a:p>
+        </p:txBody>
+      </p:sp>
+      <p:sp>
+        <p:nvSpPr>
+          <p:cNvPr id="17" name="TextBox 16"/>
           <p:cNvSpPr txBox="1"/>
           <p:nvPr/>
         </p:nvSpPr>
         <p:spPr>
           <a:xfrm>
-            <a:off x="1005840" y="3566160"/>
-            <a:ext cx="4572000" cy="822960"/>
+            <a:off x="1307592" y="3529584"/>
+            <a:ext cx="4297680" cy="347472"/>
           </a:xfrm>
           <a:prstGeom prst="rect">
             <a:avLst/>
@@ -3998,38 +4184,73 @@
           <a:p>
             <a:pPr algn="l"/>
             <a:r>
-              <a:rPr sz="1200" b="0">
-                <a:solidFill>
-                  <a:srgbClr val="000000"/>
-                </a:solidFill>
-                <a:latin typeface="Noto Sans JP"/>
+              <a:rPr sz="1200" b="1" i="0">
+                <a:solidFill>
+                  <a:srgbClr val="0F172A"/>
+                </a:solidFill>
+                <a:latin typeface="IPAGothic"/>
               </a:rPr>
-              <a:t>マネジャーが「感覚」で
-マネジメントする</a:t>
-            </a:r>
-          </a:p>
-        </p:txBody>
-      </p:sp>
-      <p:sp>
-        <p:nvSpPr>
-          <p:cNvPr id="17" name="Rectangle 16"/>
+              <a:t>マネジャーが「感覚」でマネジメントする</a:t>
+            </a:r>
+          </a:p>
+        </p:txBody>
+      </p:sp>
+      <p:sp>
+        <p:nvSpPr>
+          <p:cNvPr id="18" name="TextBox 17"/>
+          <p:cNvSpPr txBox="1"/>
+          <p:nvPr/>
+        </p:nvSpPr>
+        <p:spPr>
+          <a:xfrm>
+            <a:off x="1307592" y="3877056"/>
+            <a:ext cx="4297680" cy="841248"/>
+          </a:xfrm>
+          <a:prstGeom prst="rect">
+            <a:avLst/>
+          </a:prstGeom>
+          <a:noFill/>
+        </p:spPr>
+        <p:txBody>
+          <a:bodyPr wrap="square">
+            <a:spAutoFit/>
+          </a:bodyPr>
+          <a:lstStyle/>
+          <a:p>
+            <a:pPr algn="l"/>
+            <a:r>
+              <a:rPr sz="950" b="0" i="0">
+                <a:solidFill>
+                  <a:srgbClr val="475569"/>
+                </a:solidFill>
+                <a:latin typeface="IPAGothic"/>
+              </a:rPr>
+              <a:t>行動データが可視化されておらず、指示が
+経験値・直感に依存するため再現性がない。</a:t>
+            </a:r>
+          </a:p>
+        </p:txBody>
+      </p:sp>
+      <p:sp>
+        <p:nvSpPr>
+          <p:cNvPr id="19" name="Rectangle 18"/>
           <p:cNvSpPr/>
           <p:nvPr/>
         </p:nvSpPr>
         <p:spPr>
           <a:xfrm>
-            <a:off x="365760" y="4663440"/>
-            <a:ext cx="5303520" cy="1005840"/>
+            <a:off x="594360" y="4910328"/>
+            <a:ext cx="5120640" cy="1389888"/>
           </a:xfrm>
           <a:prstGeom prst="rect">
             <a:avLst/>
           </a:prstGeom>
           <a:solidFill>
-            <a:srgbClr val="DBEAF8"/>
+            <a:srgbClr val="EFF4FF"/>
           </a:solidFill>
-          <a:ln w="19050">
+          <a:ln w="15240">
             <a:solidFill>
-              <a:srgbClr val="275BC4"/>
+              <a:srgbClr val="DBEAFE"/>
             </a:solidFill>
           </a:ln>
         </p:spPr>
@@ -4057,20 +4278,20 @@
       </p:sp>
       <p:sp>
         <p:nvSpPr>
-          <p:cNvPr id="18" name="Rectangle 17"/>
+          <p:cNvPr id="20" name="Rectangle 19"/>
           <p:cNvSpPr/>
           <p:nvPr/>
         </p:nvSpPr>
         <p:spPr>
           <a:xfrm>
-            <a:off x="457200" y="4846320"/>
-            <a:ext cx="411480" cy="411480"/>
+            <a:off x="758952" y="5074920"/>
+            <a:ext cx="420624" cy="420624"/>
           </a:xfrm>
           <a:prstGeom prst="rect">
             <a:avLst/>
           </a:prstGeom>
           <a:solidFill>
-            <a:srgbClr val="1E3A6E"/>
+            <a:srgbClr val="1E3A8A"/>
           </a:solidFill>
           <a:ln>
             <a:noFill/>
@@ -4100,22 +4321,23 @@
                 <a:solidFill>
                   <a:srgbClr val="FFFFFF"/>
                 </a:solidFill>
+                <a:latin typeface="Calibri"/>
               </a:rPr>
-              <a:t>❸</a:t>
-            </a:r>
-          </a:p>
-        </p:txBody>
-      </p:sp>
-      <p:sp>
-        <p:nvSpPr>
-          <p:cNvPr id="19" name="TextBox 18"/>
+              <a:t>03</a:t>
+            </a:r>
+          </a:p>
+        </p:txBody>
+      </p:sp>
+      <p:sp>
+        <p:nvSpPr>
+          <p:cNvPr id="21" name="TextBox 20"/>
           <p:cNvSpPr txBox="1"/>
           <p:nvPr/>
         </p:nvSpPr>
         <p:spPr>
           <a:xfrm>
-            <a:off x="1005840" y="4754880"/>
-            <a:ext cx="4572000" cy="822960"/>
+            <a:off x="1307592" y="5038344"/>
+            <a:ext cx="4297680" cy="347472"/>
           </a:xfrm>
           <a:prstGeom prst="rect">
             <a:avLst/>
@@ -4130,34 +4352,69 @@
           <a:p>
             <a:pPr algn="l"/>
             <a:r>
-              <a:rPr sz="1200" b="0">
-                <a:solidFill>
-                  <a:srgbClr val="000000"/>
-                </a:solidFill>
-                <a:latin typeface="Noto Sans JP"/>
+              <a:rPr sz="1200" b="1" i="0">
+                <a:solidFill>
+                  <a:srgbClr val="0F172A"/>
+                </a:solidFill>
+                <a:latin typeface="IPAGothic"/>
               </a:rPr>
-              <a:t>組織が拡大しても
-売上が比例して伸びない</a:t>
-            </a:r>
-          </a:p>
-        </p:txBody>
-      </p:sp>
-      <p:sp>
-        <p:nvSpPr>
-          <p:cNvPr id="20" name="Rectangle 19"/>
+              <a:t>組織が拡大しても売上が比例して伸びない</a:t>
+            </a:r>
+          </a:p>
+        </p:txBody>
+      </p:sp>
+      <p:sp>
+        <p:nvSpPr>
+          <p:cNvPr id="22" name="TextBox 21"/>
+          <p:cNvSpPr txBox="1"/>
+          <p:nvPr/>
+        </p:nvSpPr>
+        <p:spPr>
+          <a:xfrm>
+            <a:off x="1307592" y="5385816"/>
+            <a:ext cx="4297680" cy="841248"/>
+          </a:xfrm>
+          <a:prstGeom prst="rect">
+            <a:avLst/>
+          </a:prstGeom>
+          <a:noFill/>
+        </p:spPr>
+        <p:txBody>
+          <a:bodyPr wrap="square">
+            <a:spAutoFit/>
+          </a:bodyPr>
+          <a:lstStyle/>
+          <a:p>
+            <a:pPr algn="l"/>
+            <a:r>
+              <a:rPr sz="950" b="0" i="0">
+                <a:solidFill>
+                  <a:srgbClr val="475569"/>
+                </a:solidFill>
+                <a:latin typeface="IPAGothic"/>
+              </a:rPr>
+              <a:t>人材追加コストが増加する一方、
+勝ちパターンが展開できず生産性が停滞する。</a:t>
+            </a:r>
+          </a:p>
+        </p:txBody>
+      </p:sp>
+      <p:sp>
+        <p:nvSpPr>
+          <p:cNvPr id="23" name="Rectangle 22"/>
           <p:cNvSpPr/>
           <p:nvPr/>
         </p:nvSpPr>
         <p:spPr>
           <a:xfrm>
-            <a:off x="6126480" y="1828800"/>
-            <a:ext cx="5577840" cy="365760"/>
+            <a:off x="6172200" y="1417320"/>
+            <a:ext cx="5376672" cy="384048"/>
           </a:xfrm>
           <a:prstGeom prst="rect">
             <a:avLst/>
           </a:prstGeom>
           <a:solidFill>
-            <a:srgbClr val="1E3A6E"/>
+            <a:srgbClr val="1E3A8A"/>
           </a:solidFill>
           <a:ln>
             <a:noFill/>
@@ -4178,31 +4435,23 @@
           </a:fontRef>
         </p:style>
         <p:txBody>
-          <a:bodyPr rtlCol="0" anchor="ctr" wrap="square"/>
+          <a:bodyPr rtlCol="0" anchor="ctr"/>
           <a:lstStyle/>
           <a:p>
             <a:pPr algn="ctr"/>
-            <a:r>
-              <a:rPr sz="1200" b="1">
-                <a:solidFill>
-                  <a:srgbClr val="FFFFFF"/>
-                </a:solidFill>
-              </a:rPr>
-              <a:t>売上構成比の実態</a:t>
-            </a:r>
-          </a:p>
-        </p:txBody>
-      </p:sp>
-      <p:sp>
-        <p:nvSpPr>
-          <p:cNvPr id="21" name="TextBox 20"/>
+          </a:p>
+        </p:txBody>
+      </p:sp>
+      <p:sp>
+        <p:nvSpPr>
+          <p:cNvPr id="24" name="TextBox 23"/>
           <p:cNvSpPr txBox="1"/>
           <p:nvPr/>
         </p:nvSpPr>
         <p:spPr>
           <a:xfrm>
-            <a:off x="6126480" y="2331720"/>
-            <a:ext cx="2743200" cy="320040"/>
+            <a:off x="6355080" y="1472184"/>
+            <a:ext cx="5102352" cy="292608"/>
           </a:xfrm>
           <a:prstGeom prst="rect">
             <a:avLst/>
@@ -4217,33 +4466,68 @@
           <a:p>
             <a:pPr algn="l"/>
             <a:r>
-              <a:rPr sz="1100" b="0">
-                <a:solidFill>
-                  <a:srgbClr val="000000"/>
-                </a:solidFill>
-                <a:latin typeface="Noto Sans JP"/>
+              <a:rPr sz="1100" b="1" i="0">
+                <a:solidFill>
+                  <a:srgbClr val="FFFFFF"/>
+                </a:solidFill>
+                <a:latin typeface="IPAGothic"/>
               </a:rPr>
-              <a:t>トップ20%の営業</a:t>
-            </a:r>
-          </a:p>
-        </p:txBody>
-      </p:sp>
-      <p:sp>
-        <p:nvSpPr>
-          <p:cNvPr id="22" name="Rectangle 21"/>
+              <a:t>売上構成比の実態</a:t>
+            </a:r>
+          </a:p>
+        </p:txBody>
+      </p:sp>
+      <p:sp>
+        <p:nvSpPr>
+          <p:cNvPr id="25" name="TextBox 24"/>
+          <p:cNvSpPr txBox="1"/>
+          <p:nvPr/>
+        </p:nvSpPr>
+        <p:spPr>
+          <a:xfrm>
+            <a:off x="6172200" y="2075688"/>
+            <a:ext cx="5376672" cy="256032"/>
+          </a:xfrm>
+          <a:prstGeom prst="rect">
+            <a:avLst/>
+          </a:prstGeom>
+          <a:noFill/>
+        </p:spPr>
+        <p:txBody>
+          <a:bodyPr wrap="square">
+            <a:spAutoFit/>
+          </a:bodyPr>
+          <a:lstStyle/>
+          <a:p>
+            <a:pPr algn="l"/>
+            <a:r>
+              <a:rPr sz="1000" b="0" i="0">
+                <a:solidFill>
+                  <a:srgbClr val="475569"/>
+                </a:solidFill>
+                <a:latin typeface="IPAGothic"/>
+              </a:rPr>
+              <a:t>トップ 20% の営業</a:t>
+            </a:r>
+          </a:p>
+        </p:txBody>
+      </p:sp>
+      <p:sp>
+        <p:nvSpPr>
+          <p:cNvPr id="26" name="Rectangle 25"/>
           <p:cNvSpPr/>
           <p:nvPr/>
         </p:nvSpPr>
         <p:spPr>
           <a:xfrm>
-            <a:off x="6126480" y="2651760"/>
-            <a:ext cx="4480560" cy="502920"/>
+            <a:off x="6172200" y="2331720"/>
+            <a:ext cx="3979834" cy="502920"/>
           </a:xfrm>
           <a:prstGeom prst="rect">
             <a:avLst/>
           </a:prstGeom>
           <a:solidFill>
-            <a:srgbClr val="1E3A6E"/>
+            <a:srgbClr val="1E3A8A"/>
           </a:solidFill>
           <a:ln>
             <a:noFill/>
@@ -4273,6 +4557,7 @@
                 <a:solidFill>
                   <a:srgbClr val="FFFFFF"/>
                 </a:solidFill>
+                <a:latin typeface="Calibri"/>
               </a:rPr>
               <a:t>78%</a:t>
             </a:r>
@@ -4281,14 +4566,14 @@
       </p:sp>
       <p:sp>
         <p:nvSpPr>
-          <p:cNvPr id="23" name="TextBox 22"/>
+          <p:cNvPr id="27" name="TextBox 26"/>
           <p:cNvSpPr txBox="1"/>
           <p:nvPr/>
         </p:nvSpPr>
         <p:spPr>
           <a:xfrm>
-            <a:off x="6126480" y="3291840"/>
-            <a:ext cx="2743200" cy="320040"/>
+            <a:off x="6172200" y="3236976"/>
+            <a:ext cx="5376672" cy="256032"/>
           </a:xfrm>
           <a:prstGeom prst="rect">
             <a:avLst/>
@@ -4303,33 +4588,33 @@
           <a:p>
             <a:pPr algn="l"/>
             <a:r>
-              <a:rPr sz="1100" b="0">
-                <a:solidFill>
-                  <a:srgbClr val="000000"/>
-                </a:solidFill>
-                <a:latin typeface="Noto Sans JP"/>
+              <a:rPr sz="1000" b="0" i="0">
+                <a:solidFill>
+                  <a:srgbClr val="475569"/>
+                </a:solidFill>
+                <a:latin typeface="IPAGothic"/>
               </a:rPr>
-              <a:t>残り80%の営業</a:t>
-            </a:r>
-          </a:p>
-        </p:txBody>
-      </p:sp>
-      <p:sp>
-        <p:nvSpPr>
-          <p:cNvPr id="24" name="Rectangle 23"/>
+              <a:t>残り 80% の営業</a:t>
+            </a:r>
+          </a:p>
+        </p:txBody>
+      </p:sp>
+      <p:sp>
+        <p:nvSpPr>
+          <p:cNvPr id="28" name="Rectangle 27"/>
           <p:cNvSpPr/>
           <p:nvPr/>
         </p:nvSpPr>
         <p:spPr>
           <a:xfrm>
-            <a:off x="6126480" y="3611880"/>
-            <a:ext cx="1234440" cy="502920"/>
+            <a:off x="6172200" y="3493008"/>
+            <a:ext cx="1122517" cy="502920"/>
           </a:xfrm>
           <a:prstGeom prst="rect">
             <a:avLst/>
           </a:prstGeom>
           <a:solidFill>
-            <a:srgbClr val="275BC4"/>
+            <a:srgbClr val="2563EB"/>
           </a:solidFill>
           <a:ln>
             <a:noFill/>
@@ -4359,6 +4644,7 @@
                 <a:solidFill>
                   <a:srgbClr val="FFFFFF"/>
                 </a:solidFill>
+                <a:latin typeface="Calibri"/>
               </a:rPr>
               <a:t>22%</a:t>
             </a:r>
@@ -4367,24 +4653,24 @@
       </p:sp>
       <p:sp>
         <p:nvSpPr>
-          <p:cNvPr id="25" name="Rectangle 24"/>
+          <p:cNvPr id="29" name="Rectangle 28"/>
           <p:cNvSpPr/>
           <p:nvPr/>
         </p:nvSpPr>
         <p:spPr>
           <a:xfrm>
-            <a:off x="6126480" y="4572000"/>
-            <a:ext cx="5577840" cy="1005840"/>
+            <a:off x="6172200" y="3977640"/>
+            <a:ext cx="5376672" cy="1691640"/>
           </a:xfrm>
           <a:prstGeom prst="rect">
             <a:avLst/>
           </a:prstGeom>
           <a:solidFill>
-            <a:srgbClr val="DBEAF8"/>
+            <a:srgbClr val="EFF4FF"/>
           </a:solidFill>
           <a:ln w="25400">
             <a:solidFill>
-              <a:srgbClr val="275BC4"/>
+              <a:srgbClr val="2563EB"/>
             </a:solidFill>
           </a:ln>
         </p:spPr>
@@ -4412,14 +4698,14 @@
       </p:sp>
       <p:sp>
         <p:nvSpPr>
-          <p:cNvPr id="26" name="TextBox 25"/>
+          <p:cNvPr id="30" name="TextBox 29"/>
           <p:cNvSpPr txBox="1"/>
           <p:nvPr/>
         </p:nvSpPr>
         <p:spPr>
           <a:xfrm>
-            <a:off x="6309360" y="4617720"/>
-            <a:ext cx="5212080" cy="914400"/>
+            <a:off x="6428232" y="4142232"/>
+            <a:ext cx="5010912" cy="292608"/>
           </a:xfrm>
           <a:prstGeom prst="rect">
             <a:avLst/>
@@ -4434,14 +4720,49 @@
           <a:p>
             <a:pPr algn="l"/>
             <a:r>
-              <a:rPr sz="1300" b="1">
-                <a:solidFill>
-                  <a:srgbClr val="1E3A6E"/>
-                </a:solidFill>
-                <a:latin typeface="Noto Sans JP"/>
+              <a:rPr sz="1000" b="1" i="0">
+                <a:solidFill>
+                  <a:srgbClr val="2563EB"/>
+                </a:solidFill>
+                <a:latin typeface="IPAGothic"/>
               </a:rPr>
-              <a:t>→ 個人の「才能」ではなく、
-　 仕組みで再現することが急務</a:t>
+              <a:t>→ 結論</a:t>
+            </a:r>
+          </a:p>
+        </p:txBody>
+      </p:sp>
+      <p:sp>
+        <p:nvSpPr>
+          <p:cNvPr id="31" name="TextBox 30"/>
+          <p:cNvSpPr txBox="1"/>
+          <p:nvPr/>
+        </p:nvSpPr>
+        <p:spPr>
+          <a:xfrm>
+            <a:off x="6428232" y="4434840"/>
+            <a:ext cx="5010912" cy="1051560"/>
+          </a:xfrm>
+          <a:prstGeom prst="rect">
+            <a:avLst/>
+          </a:prstGeom>
+          <a:noFill/>
+        </p:spPr>
+        <p:txBody>
+          <a:bodyPr wrap="square">
+            <a:spAutoFit/>
+          </a:bodyPr>
+          <a:lstStyle/>
+          <a:p>
+            <a:pPr algn="l"/>
+            <a:r>
+              <a:rPr sz="1200" b="1" i="0">
+                <a:solidFill>
+                  <a:srgbClr val="1E3A8A"/>
+                </a:solidFill>
+                <a:latin typeface="IPAGothic"/>
+              </a:rPr>
+              <a:t>個人の「才能」に依存した営業から脱却し、
+データと仕組みで誰もが成果を出せる組織へ転換することが急務。</a:t>
             </a:r>
           </a:p>
         </p:txBody>
@@ -4464,87 +4785,9 @@
         <p:nvPr/>
       </p:nvGrpSpPr>
       <p:grpSpPr/>
-      <p:sp>
-        <p:nvSpPr>
-          <p:cNvPr id="2" name="Rectangle 1"/>
-          <p:cNvSpPr/>
-          <p:nvPr/>
-        </p:nvSpPr>
-        <p:spPr>
-          <a:xfrm>
-            <a:off x="365760" y="685800"/>
-            <a:ext cx="11430000" cy="19050"/>
-          </a:xfrm>
-          <a:prstGeom prst="rect">
-            <a:avLst/>
-          </a:prstGeom>
-          <a:solidFill>
-            <a:srgbClr val="000000"/>
-          </a:solidFill>
-          <a:ln>
-            <a:noFill/>
-          </a:ln>
-        </p:spPr>
-        <p:style>
-          <a:lnRef idx="1">
-            <a:schemeClr val="accent1"/>
-          </a:lnRef>
-          <a:fillRef idx="3">
-            <a:schemeClr val="accent1"/>
-          </a:fillRef>
-          <a:effectRef idx="2">
-            <a:schemeClr val="accent1"/>
-          </a:effectRef>
-          <a:fontRef idx="minor">
-            <a:schemeClr val="lt1"/>
-          </a:fontRef>
-        </p:style>
-        <p:txBody>
-          <a:bodyPr rtlCol="0" anchor="ctr"/>
-          <a:lstStyle/>
-          <a:p>
-            <a:pPr algn="ctr"/>
-          </a:p>
-        </p:txBody>
-      </p:sp>
-      <p:sp>
-        <p:nvSpPr>
-          <p:cNvPr id="3" name="TextBox 2"/>
-          <p:cNvSpPr txBox="1"/>
-          <p:nvPr/>
-        </p:nvSpPr>
-        <p:spPr>
-          <a:xfrm>
-            <a:off x="365760" y="137160"/>
-            <a:ext cx="7315200" cy="548640"/>
-          </a:xfrm>
-          <a:prstGeom prst="rect">
-            <a:avLst/>
-          </a:prstGeom>
-          <a:noFill/>
-        </p:spPr>
-        <p:txBody>
-          <a:bodyPr wrap="square">
-            <a:spAutoFit/>
-          </a:bodyPr>
-          <a:lstStyle/>
-          <a:p>
-            <a:pPr algn="l"/>
-            <a:r>
-              <a:rPr sz="1800" b="1">
-                <a:solidFill>
-                  <a:srgbClr val="000000"/>
-                </a:solidFill>
-                <a:latin typeface="Noto Sans JP"/>
-              </a:rPr>
-              <a:t>営業生産性を2倍にする「3つのアクション」</a:t>
-            </a:r>
-          </a:p>
-        </p:txBody>
-      </p:sp>
       <p:pic>
         <p:nvPicPr>
-          <p:cNvPr id="4" name="Picture 3" descr="salescore_logo.png"/>
+          <p:cNvPr id="2" name="Picture 1" descr="salescore_logo.png"/>
           <p:cNvPicPr>
             <a:picLocks noChangeAspect="1"/>
           </p:cNvPicPr>
@@ -4558,8 +4801,8 @@
         </p:blipFill>
         <p:spPr>
           <a:xfrm>
-            <a:off x="9875520" y="73152"/>
-            <a:ext cx="1920240" cy="566928"/>
+            <a:off x="9948672" y="164592"/>
+            <a:ext cx="1737360" cy="475488"/>
           </a:xfrm>
           <a:prstGeom prst="rect">
             <a:avLst/>
@@ -4568,20 +4811,55 @@
       </p:pic>
       <p:sp>
         <p:nvSpPr>
-          <p:cNvPr id="5" name="Rectangle 4"/>
+          <p:cNvPr id="3" name="TextBox 2"/>
+          <p:cNvSpPr txBox="1"/>
+          <p:nvPr/>
+        </p:nvSpPr>
+        <p:spPr>
+          <a:xfrm>
+            <a:off x="594360" y="182880"/>
+            <a:ext cx="8961120" cy="548640"/>
+          </a:xfrm>
+          <a:prstGeom prst="rect">
+            <a:avLst/>
+          </a:prstGeom>
+          <a:noFill/>
+        </p:spPr>
+        <p:txBody>
+          <a:bodyPr wrap="square">
+            <a:spAutoFit/>
+          </a:bodyPr>
+          <a:lstStyle/>
+          <a:p>
+            <a:pPr algn="l"/>
+            <a:r>
+              <a:rPr sz="2000" b="1" i="0">
+                <a:solidFill>
+                  <a:srgbClr val="0F172A"/>
+                </a:solidFill>
+                <a:latin typeface="IPAGothic"/>
+              </a:rPr>
+              <a:t>営業生産性を2倍にする「3つのアクション」</a:t>
+            </a:r>
+          </a:p>
+        </p:txBody>
+      </p:sp>
+      <p:sp>
+        <p:nvSpPr>
+          <p:cNvPr id="4" name="Rectangle 3"/>
           <p:cNvSpPr/>
           <p:nvPr/>
         </p:nvSpPr>
         <p:spPr>
           <a:xfrm>
-            <a:off x="365760" y="6400800"/>
-            <a:ext cx="11430000" cy="19050"/>
+            <a:off x="594360" y="749808"/>
+            <a:ext cx="11000232" cy="31750"/>
           </a:xfrm>
           <a:prstGeom prst="rect">
             <a:avLst/>
           </a:prstGeom>
           <a:solidFill>
-            <a:srgbClr val="000000"/>
+            <a:srgbClr val="1E3A8A"/>
           </a:solidFill>
           <a:ln>
             <a:noFill/>
@@ -4611,160 +4889,20 @@
       </p:sp>
       <p:sp>
         <p:nvSpPr>
-          <p:cNvPr id="6" name="TextBox 5"/>
-          <p:cNvSpPr txBox="1"/>
-          <p:nvPr/>
-        </p:nvSpPr>
-        <p:spPr>
-          <a:xfrm>
-            <a:off x="365760" y="6446520"/>
-            <a:ext cx="9144000" cy="320040"/>
-          </a:xfrm>
-          <a:prstGeom prst="rect">
-            <a:avLst/>
-          </a:prstGeom>
-          <a:noFill/>
-        </p:spPr>
-        <p:txBody>
-          <a:bodyPr wrap="square">
-            <a:spAutoFit/>
-          </a:bodyPr>
-          <a:lstStyle/>
-          <a:p>
-            <a:pPr algn="l"/>
-            <a:r>
-              <a:rPr sz="800" b="0">
-                <a:solidFill>
-                  <a:srgbClr val="9CA3AF"/>
-                </a:solidFill>
-                <a:latin typeface="Noto Sans JP"/>
-              </a:rPr>
-              <a:t>Confidential All Rights Reserved SALESCORE Inc.</a:t>
-            </a:r>
-          </a:p>
-        </p:txBody>
-      </p:sp>
-      <p:sp>
-        <p:nvSpPr>
-          <p:cNvPr id="7" name="TextBox 6"/>
-          <p:cNvSpPr txBox="1"/>
-          <p:nvPr/>
-        </p:nvSpPr>
-        <p:spPr>
-          <a:xfrm>
-            <a:off x="11430000" y="6446520"/>
-            <a:ext cx="365760" cy="320040"/>
-          </a:xfrm>
-          <a:prstGeom prst="rect">
-            <a:avLst/>
-          </a:prstGeom>
-          <a:noFill/>
-        </p:spPr>
-        <p:txBody>
-          <a:bodyPr wrap="square">
-            <a:spAutoFit/>
-          </a:bodyPr>
-          <a:lstStyle/>
-          <a:p>
-            <a:pPr algn="r"/>
-            <a:r>
-              <a:rPr sz="1000" b="0">
-                <a:solidFill>
-                  <a:srgbClr val="000000"/>
-                </a:solidFill>
-                <a:latin typeface="Noto Sans JP"/>
-              </a:rPr>
-              <a:t>3</a:t>
-            </a:r>
-          </a:p>
-        </p:txBody>
-      </p:sp>
-      <p:sp>
-        <p:nvSpPr>
-          <p:cNvPr id="8" name="TextBox 7"/>
-          <p:cNvSpPr txBox="1"/>
-          <p:nvPr/>
-        </p:nvSpPr>
-        <p:spPr>
-          <a:xfrm>
-            <a:off x="365760" y="822960"/>
-            <a:ext cx="11430000" cy="411480"/>
-          </a:xfrm>
-          <a:prstGeom prst="rect">
-            <a:avLst/>
-          </a:prstGeom>
-          <a:noFill/>
-        </p:spPr>
-        <p:txBody>
-          <a:bodyPr wrap="square">
-            <a:spAutoFit/>
-          </a:bodyPr>
-          <a:lstStyle/>
-          <a:p>
-            <a:pPr algn="l"/>
-            <a:r>
-              <a:rPr sz="1200" b="0">
-                <a:solidFill>
-                  <a:srgbClr val="000000"/>
-                </a:solidFill>
-                <a:latin typeface="Noto Sans JP"/>
-              </a:rPr>
-              <a:t>データで行動を可視化し、再現可能な仕組みに変換することで、組織全体の底上げが実現できる</a:t>
-            </a:r>
-          </a:p>
-        </p:txBody>
-      </p:sp>
-      <p:sp>
-        <p:nvSpPr>
-          <p:cNvPr id="9" name="TextBox 8"/>
-          <p:cNvSpPr txBox="1"/>
-          <p:nvPr/>
-        </p:nvSpPr>
-        <p:spPr>
-          <a:xfrm>
-            <a:off x="365760" y="1325880"/>
-            <a:ext cx="11430000" cy="320040"/>
-          </a:xfrm>
-          <a:prstGeom prst="rect">
-            <a:avLst/>
-          </a:prstGeom>
-          <a:noFill/>
-        </p:spPr>
-        <p:txBody>
-          <a:bodyPr wrap="square">
-            <a:spAutoFit/>
-          </a:bodyPr>
-          <a:lstStyle/>
-          <a:p>
-            <a:pPr algn="ctr"/>
-            <a:r>
-              <a:rPr sz="1100" b="0">
-                <a:solidFill>
-                  <a:srgbClr val="275BC4"/>
-                </a:solidFill>
-                <a:latin typeface="Noto Sans JP"/>
-              </a:rPr>
-              <a:t>◀━━━━━━ 約1〜2ヶ月 ━━━━━━▶</a:t>
-            </a:r>
-          </a:p>
-        </p:txBody>
-      </p:sp>
-      <p:sp>
-        <p:nvSpPr>
-          <p:cNvPr id="10" name="Rectangle 9"/>
+          <p:cNvPr id="5" name="Rectangle 4"/>
           <p:cNvSpPr/>
           <p:nvPr/>
         </p:nvSpPr>
         <p:spPr>
           <a:xfrm>
-            <a:off x="365760" y="1737360"/>
-            <a:ext cx="3474720" cy="1005840"/>
+            <a:off x="594360" y="6327648"/>
+            <a:ext cx="11000232" cy="12700"/>
           </a:xfrm>
           <a:prstGeom prst="rect">
             <a:avLst/>
           </a:prstGeom>
           <a:solidFill>
-            <a:srgbClr val="1E3A6E"/>
+            <a:srgbClr val="CBD5E1"/>
           </a:solidFill>
           <a:ln>
             <a:noFill/>
@@ -4794,14 +4932,14 @@
       </p:sp>
       <p:sp>
         <p:nvSpPr>
-          <p:cNvPr id="11" name="TextBox 10"/>
+          <p:cNvPr id="6" name="TextBox 5"/>
           <p:cNvSpPr txBox="1"/>
           <p:nvPr/>
         </p:nvSpPr>
         <p:spPr>
           <a:xfrm>
-            <a:off x="457200" y="1783080"/>
-            <a:ext cx="3291840" cy="914400"/>
+            <a:off x="594360" y="6373368"/>
+            <a:ext cx="8686800" cy="320040"/>
           </a:xfrm>
           <a:prstGeom prst="rect">
             <a:avLst/>
@@ -4814,32 +4952,29 @@
           </a:bodyPr>
           <a:lstStyle/>
           <a:p>
-            <a:pPr algn="ctr"/>
-            <a:r>
-              <a:rPr sz="1300" b="1">
-                <a:solidFill>
-                  <a:srgbClr val="FFFFFF"/>
-                </a:solidFill>
-                <a:latin typeface="Noto Sans JP"/>
+            <a:pPr algn="l"/>
+            <a:r>
+              <a:rPr sz="800" b="0" i="0">
+                <a:solidFill>
+                  <a:srgbClr val="94A3B8"/>
+                </a:solidFill>
+                <a:latin typeface="Calibri"/>
               </a:rPr>
-              <a:t>ACTION
-01
-Keyアクション
-特定</a:t>
-            </a:r>
-          </a:p>
-        </p:txBody>
-      </p:sp>
-      <p:sp>
-        <p:nvSpPr>
-          <p:cNvPr id="12" name="TextBox 11"/>
+              <a:t>Confidential  All Rights Reserved SALESCORE Inc.</a:t>
+            </a:r>
+          </a:p>
+        </p:txBody>
+      </p:sp>
+      <p:sp>
+        <p:nvSpPr>
+          <p:cNvPr id="7" name="TextBox 6"/>
           <p:cNvSpPr txBox="1"/>
           <p:nvPr/>
         </p:nvSpPr>
         <p:spPr>
           <a:xfrm>
-            <a:off x="3749039" y="2011680"/>
-            <a:ext cx="274320" cy="457200"/>
+            <a:off x="11430000" y="6373368"/>
+            <a:ext cx="457200" cy="320040"/>
           </a:xfrm>
           <a:prstGeom prst="rect">
             <a:avLst/>
@@ -4852,35 +4987,70 @@
           </a:bodyPr>
           <a:lstStyle/>
           <a:p>
-            <a:pPr algn="ctr"/>
-            <a:r>
-              <a:rPr sz="1600" b="0">
-                <a:solidFill>
-                  <a:srgbClr val="1E3A6E"/>
-                </a:solidFill>
-                <a:latin typeface="Noto Sans JP"/>
+            <a:pPr algn="r"/>
+            <a:r>
+              <a:rPr sz="900" b="0" i="0">
+                <a:solidFill>
+                  <a:srgbClr val="94A3B8"/>
+                </a:solidFill>
+                <a:latin typeface="Calibri"/>
               </a:rPr>
-              <a:t>▶</a:t>
-            </a:r>
-          </a:p>
-        </p:txBody>
-      </p:sp>
-      <p:sp>
-        <p:nvSpPr>
-          <p:cNvPr id="13" name="Rectangle 12"/>
+              <a:t>3</a:t>
+            </a:r>
+          </a:p>
+        </p:txBody>
+      </p:sp>
+      <p:sp>
+        <p:nvSpPr>
+          <p:cNvPr id="8" name="TextBox 7"/>
+          <p:cNvSpPr txBox="1"/>
+          <p:nvPr/>
+        </p:nvSpPr>
+        <p:spPr>
+          <a:xfrm>
+            <a:off x="594360" y="960120"/>
+            <a:ext cx="10058400" cy="365760"/>
+          </a:xfrm>
+          <a:prstGeom prst="rect">
+            <a:avLst/>
+          </a:prstGeom>
+          <a:noFill/>
+        </p:spPr>
+        <p:txBody>
+          <a:bodyPr wrap="square">
+            <a:spAutoFit/>
+          </a:bodyPr>
+          <a:lstStyle/>
+          <a:p>
+            <a:pPr algn="l"/>
+            <a:r>
+              <a:rPr sz="1100" b="0" i="0">
+                <a:solidFill>
+                  <a:srgbClr val="475569"/>
+                </a:solidFill>
+                <a:latin typeface="IPAGothic"/>
+              </a:rPr>
+              <a:t>データで行動を可視化し、再現可能な仕組みに変換することで、組織全体の底上げが実現できる</a:t>
+            </a:r>
+          </a:p>
+        </p:txBody>
+      </p:sp>
+      <p:sp>
+        <p:nvSpPr>
+          <p:cNvPr id="9" name="Rectangle 8"/>
           <p:cNvSpPr/>
           <p:nvPr/>
         </p:nvSpPr>
         <p:spPr>
           <a:xfrm>
-            <a:off x="4297680" y="1737360"/>
-            <a:ext cx="3474720" cy="1005840"/>
+            <a:off x="594360" y="1444752"/>
+            <a:ext cx="11000232" cy="25400"/>
           </a:xfrm>
           <a:prstGeom prst="rect">
             <a:avLst/>
           </a:prstGeom>
           <a:solidFill>
-            <a:srgbClr val="1E3A6E"/>
+            <a:srgbClr val="CBD5E1"/>
           </a:solidFill>
           <a:ln>
             <a:noFill/>
@@ -4910,14 +5080,14 @@
       </p:sp>
       <p:sp>
         <p:nvSpPr>
-          <p:cNvPr id="14" name="TextBox 13"/>
+          <p:cNvPr id="10" name="TextBox 9"/>
           <p:cNvSpPr txBox="1"/>
           <p:nvPr/>
         </p:nvSpPr>
         <p:spPr>
           <a:xfrm>
-            <a:off x="4389120" y="1783080"/>
-            <a:ext cx="3291840" cy="914400"/>
+            <a:off x="594360" y="1170432"/>
+            <a:ext cx="11000232" cy="256032"/>
           </a:xfrm>
           <a:prstGeom prst="rect">
             <a:avLst/>
@@ -4932,71 +5102,33 @@
           <a:p>
             <a:pPr algn="ctr"/>
             <a:r>
-              <a:rPr sz="1300" b="1">
-                <a:solidFill>
-                  <a:srgbClr val="FFFFFF"/>
-                </a:solidFill>
-                <a:latin typeface="Noto Sans JP"/>
+              <a:rPr sz="950" b="0" i="0">
+                <a:solidFill>
+                  <a:srgbClr val="2563EB"/>
+                </a:solidFill>
+                <a:latin typeface="IPAGothic"/>
               </a:rPr>
-              <a:t>ACTION
-02
-仕組み
-実装</a:t>
-            </a:r>
-          </a:p>
-        </p:txBody>
-      </p:sp>
-      <p:sp>
-        <p:nvSpPr>
-          <p:cNvPr id="15" name="TextBox 14"/>
-          <p:cNvSpPr txBox="1"/>
-          <p:nvPr/>
-        </p:nvSpPr>
-        <p:spPr>
-          <a:xfrm>
-            <a:off x="7680959" y="2011680"/>
-            <a:ext cx="274320" cy="457200"/>
-          </a:xfrm>
-          <a:prstGeom prst="rect">
-            <a:avLst/>
-          </a:prstGeom>
-          <a:noFill/>
-        </p:spPr>
-        <p:txBody>
-          <a:bodyPr wrap="square">
-            <a:spAutoFit/>
-          </a:bodyPr>
-          <a:lstStyle/>
-          <a:p>
-            <a:pPr algn="ctr"/>
-            <a:r>
-              <a:rPr sz="1600" b="0">
-                <a:solidFill>
-                  <a:srgbClr val="1E3A6E"/>
-                </a:solidFill>
-                <a:latin typeface="Noto Sans JP"/>
-              </a:rPr>
-              <a:t>▶</a:t>
-            </a:r>
-          </a:p>
-        </p:txBody>
-      </p:sp>
-      <p:sp>
-        <p:nvSpPr>
-          <p:cNvPr id="16" name="Rectangle 15"/>
+              <a:t>◀  導入から約 1〜2 ヶ月で成果検証フェーズへ  ▶</a:t>
+            </a:r>
+          </a:p>
+        </p:txBody>
+      </p:sp>
+      <p:sp>
+        <p:nvSpPr>
+          <p:cNvPr id="11" name="Rectangle 10"/>
           <p:cNvSpPr/>
           <p:nvPr/>
         </p:nvSpPr>
         <p:spPr>
           <a:xfrm>
-            <a:off x="8229600" y="1737360"/>
-            <a:ext cx="3474720" cy="1005840"/>
+            <a:off x="594360" y="1508760"/>
+            <a:ext cx="3474720" cy="1078992"/>
           </a:xfrm>
           <a:prstGeom prst="rect">
             <a:avLst/>
           </a:prstGeom>
           <a:solidFill>
-            <a:srgbClr val="1E3A6E"/>
+            <a:srgbClr val="1E3A8A"/>
           </a:solidFill>
           <a:ln>
             <a:noFill/>
@@ -5026,14 +5158,14 @@
       </p:sp>
       <p:sp>
         <p:nvSpPr>
-          <p:cNvPr id="17" name="TextBox 16"/>
+          <p:cNvPr id="12" name="TextBox 11"/>
           <p:cNvSpPr txBox="1"/>
           <p:nvPr/>
         </p:nvSpPr>
         <p:spPr>
           <a:xfrm>
-            <a:off x="8321040" y="1783080"/>
-            <a:ext cx="3291840" cy="914400"/>
+            <a:off x="758952" y="1618488"/>
+            <a:ext cx="3291840" cy="256032"/>
           </a:xfrm>
           <a:prstGeom prst="rect">
             <a:avLst/>
@@ -5048,30 +5180,27 @@
           <a:p>
             <a:pPr algn="ctr"/>
             <a:r>
-              <a:rPr sz="1300" b="1">
-                <a:solidFill>
-                  <a:srgbClr val="FFFFFF"/>
-                </a:solidFill>
-                <a:latin typeface="Noto Sans JP"/>
+              <a:rPr sz="900" b="1" i="0">
+                <a:solidFill>
+                  <a:srgbClr val="3B82F6"/>
+                </a:solidFill>
+                <a:latin typeface="Calibri"/>
               </a:rPr>
-              <a:t>ACTION
-03
-習慣化
-定着</a:t>
-            </a:r>
-          </a:p>
-        </p:txBody>
-      </p:sp>
-      <p:sp>
-        <p:nvSpPr>
-          <p:cNvPr id="18" name="TextBox 17"/>
+              <a:t>ACTION  01</a:t>
+            </a:r>
+          </a:p>
+        </p:txBody>
+      </p:sp>
+      <p:sp>
+        <p:nvSpPr>
+          <p:cNvPr id="13" name="TextBox 12"/>
           <p:cNvSpPr txBox="1"/>
           <p:nvPr/>
         </p:nvSpPr>
         <p:spPr>
           <a:xfrm>
-            <a:off x="365760" y="2834640"/>
-            <a:ext cx="3474720" cy="1097280"/>
+            <a:off x="704088" y="1892808"/>
+            <a:ext cx="3255264" cy="621792"/>
           </a:xfrm>
           <a:prstGeom prst="rect">
             <a:avLst/>
@@ -5084,31 +5213,29 @@
           </a:bodyPr>
           <a:lstStyle/>
           <a:p>
-            <a:pPr algn="l"/>
-            <a:r>
-              <a:rPr sz="1000" b="0">
-                <a:solidFill>
-                  <a:srgbClr val="000000"/>
-                </a:solidFill>
-                <a:latin typeface="Noto Sans JP"/>
+            <a:pPr algn="ctr"/>
+            <a:r>
+              <a:rPr sz="1600" b="1" i="0">
+                <a:solidFill>
+                  <a:srgbClr val="FFFFFF"/>
+                </a:solidFill>
+                <a:latin typeface="IPAGothic"/>
               </a:rPr>
-              <a:t>・お打ち合わせ段階で
-　録画視聴やインタビューを実施
-・勝ちパターンの仮説設計</a:t>
-            </a:r>
-          </a:p>
-        </p:txBody>
-      </p:sp>
-      <p:sp>
-        <p:nvSpPr>
-          <p:cNvPr id="19" name="TextBox 18"/>
+              <a:t>Key アクション特定</a:t>
+            </a:r>
+          </a:p>
+        </p:txBody>
+      </p:sp>
+      <p:sp>
+        <p:nvSpPr>
+          <p:cNvPr id="14" name="TextBox 13"/>
           <p:cNvSpPr txBox="1"/>
           <p:nvPr/>
         </p:nvSpPr>
         <p:spPr>
           <a:xfrm>
-            <a:off x="4297680" y="2834640"/>
-            <a:ext cx="3474720" cy="1097280"/>
+            <a:off x="4105656" y="1874520"/>
+            <a:ext cx="301752" cy="365760"/>
           </a:xfrm>
           <a:prstGeom prst="rect">
             <a:avLst/>
@@ -5121,78 +5248,39 @@
           </a:bodyPr>
           <a:lstStyle/>
           <a:p>
-            <a:pPr algn="l"/>
-            <a:r>
-              <a:rPr sz="1000" b="0">
-                <a:solidFill>
-                  <a:srgbClr val="000000"/>
-                </a:solidFill>
-                <a:latin typeface="Noto Sans JP"/>
+            <a:pPr algn="ctr"/>
+            <a:r>
+              <a:rPr sz="1100" b="0" i="0">
+                <a:solidFill>
+                  <a:srgbClr val="1E3A8A"/>
+                </a:solidFill>
+                <a:latin typeface="Calibri"/>
               </a:rPr>
-              <a:t>・KeyアクションをKPIに実装
-・会議体・ダッシュボード設計
-・現場への運用説明会</a:t>
-            </a:r>
-          </a:p>
-        </p:txBody>
-      </p:sp>
-      <p:sp>
-        <p:nvSpPr>
-          <p:cNvPr id="20" name="TextBox 19"/>
-          <p:cNvSpPr txBox="1"/>
-          <p:nvPr/>
-        </p:nvSpPr>
-        <p:spPr>
-          <a:xfrm>
-            <a:off x="8229600" y="2834640"/>
-            <a:ext cx="3474720" cy="1097280"/>
-          </a:xfrm>
-          <a:prstGeom prst="rect">
-            <a:avLst/>
-          </a:prstGeom>
-          <a:noFill/>
-        </p:spPr>
-        <p:txBody>
-          <a:bodyPr wrap="square">
-            <a:spAutoFit/>
-          </a:bodyPr>
-          <a:lstStyle/>
-          <a:p>
-            <a:pPr algn="l"/>
-            <a:r>
-              <a:rPr sz="1000" b="0">
-                <a:solidFill>
-                  <a:srgbClr val="000000"/>
-                </a:solidFill>
-                <a:latin typeface="Noto Sans JP"/>
-              </a:rPr>
-              <a:t>・日々の会議体で進捗確認
-・ブロッカーをタイムリー排除
-・アジャイルに磨き込み</a:t>
-            </a:r>
-          </a:p>
-        </p:txBody>
-      </p:sp>
-      <p:sp>
-        <p:nvSpPr>
-          <p:cNvPr id="21" name="Rectangle 20"/>
+              <a:t>▶</a:t>
+            </a:r>
+          </a:p>
+        </p:txBody>
+      </p:sp>
+      <p:sp>
+        <p:nvSpPr>
+          <p:cNvPr id="15" name="Rectangle 14"/>
           <p:cNvSpPr/>
           <p:nvPr/>
         </p:nvSpPr>
         <p:spPr>
           <a:xfrm>
-            <a:off x="365760" y="4114800"/>
-            <a:ext cx="3474720" cy="1463040"/>
+            <a:off x="594360" y="2715768"/>
+            <a:ext cx="3474720" cy="1572768"/>
           </a:xfrm>
           <a:prstGeom prst="rect">
             <a:avLst/>
           </a:prstGeom>
           <a:solidFill>
-            <a:srgbClr val="FFFFFF"/>
+            <a:srgbClr val="EFF4FF"/>
           </a:solidFill>
-          <a:ln w="25400">
+          <a:ln w="10160">
             <a:solidFill>
-              <a:srgbClr val="275BC4"/>
+              <a:srgbClr val="DBEAFE"/>
             </a:solidFill>
           </a:ln>
         </p:spPr>
@@ -5220,20 +5308,58 @@
       </p:sp>
       <p:sp>
         <p:nvSpPr>
-          <p:cNvPr id="22" name="Rectangle 21"/>
+          <p:cNvPr id="16" name="TextBox 15"/>
+          <p:cNvSpPr txBox="1"/>
+          <p:nvPr/>
+        </p:nvSpPr>
+        <p:spPr>
+          <a:xfrm>
+            <a:off x="758952" y="2825496"/>
+            <a:ext cx="3218688" cy="1389888"/>
+          </a:xfrm>
+          <a:prstGeom prst="rect">
+            <a:avLst/>
+          </a:prstGeom>
+          <a:noFill/>
+        </p:spPr>
+        <p:txBody>
+          <a:bodyPr wrap="square">
+            <a:spAutoFit/>
+          </a:bodyPr>
+          <a:lstStyle/>
+          <a:p>
+            <a:pPr algn="l"/>
+            <a:r>
+              <a:rPr sz="950" b="0" i="0">
+                <a:solidFill>
+                  <a:srgbClr val="0F172A"/>
+                </a:solidFill>
+                <a:latin typeface="IPAGothic"/>
+              </a:rPr>
+              <a:t>・お打ち合わせ段階で
+　 録画視聴・インタビューを実施
+・トップ営業の行動パターン分析
+・勝ちパターンの仮説設計</a:t>
+            </a:r>
+          </a:p>
+        </p:txBody>
+      </p:sp>
+      <p:sp>
+        <p:nvSpPr>
+          <p:cNvPr id="17" name="Rectangle 16"/>
           <p:cNvSpPr/>
           <p:nvPr/>
         </p:nvSpPr>
         <p:spPr>
           <a:xfrm>
-            <a:off x="1737360" y="3886200"/>
-            <a:ext cx="731520" cy="457200"/>
+            <a:off x="1783080" y="4562856"/>
+            <a:ext cx="1097280" cy="292608"/>
           </a:xfrm>
           <a:prstGeom prst="rect">
             <a:avLst/>
           </a:prstGeom>
           <a:solidFill>
-            <a:srgbClr val="1E3A6E"/>
+            <a:srgbClr val="1E3A8A"/>
           </a:solidFill>
           <a:ln>
             <a:noFill/>
@@ -5263,59 +5389,23 @@
                 <a:solidFill>
                   <a:srgbClr val="FFFFFF"/>
                 </a:solidFill>
+                <a:latin typeface="IPAGothic"/>
               </a:rPr>
-              <a:t>利点
-01</a:t>
-            </a:r>
-          </a:p>
-        </p:txBody>
-      </p:sp>
-      <p:sp>
-        <p:nvSpPr>
-          <p:cNvPr id="23" name="TextBox 22"/>
-          <p:cNvSpPr txBox="1"/>
-          <p:nvPr/>
-        </p:nvSpPr>
-        <p:spPr>
-          <a:xfrm>
-            <a:off x="457200" y="4389120"/>
-            <a:ext cx="3291840" cy="1005840"/>
-          </a:xfrm>
-          <a:prstGeom prst="rect">
-            <a:avLst/>
-          </a:prstGeom>
-          <a:noFill/>
-        </p:spPr>
-        <p:txBody>
-          <a:bodyPr wrap="square">
-            <a:spAutoFit/>
-          </a:bodyPr>
-          <a:lstStyle/>
-          <a:p>
-            <a:pPr algn="ctr"/>
-            <a:r>
-              <a:rPr sz="1200" b="1">
-                <a:solidFill>
-                  <a:srgbClr val="1E3A6E"/>
-                </a:solidFill>
-                <a:latin typeface="Noto Sans JP"/>
-              </a:rPr>
-              <a:t>短期で成果出しの
-検証まで実行できる</a:t>
-            </a:r>
-          </a:p>
-        </p:txBody>
-      </p:sp>
-      <p:sp>
-        <p:nvSpPr>
-          <p:cNvPr id="24" name="Rectangle 23"/>
+              <a:t>利点  01</a:t>
+            </a:r>
+          </a:p>
+        </p:txBody>
+      </p:sp>
+      <p:sp>
+        <p:nvSpPr>
+          <p:cNvPr id="18" name="Rectangle 17"/>
           <p:cNvSpPr/>
           <p:nvPr/>
         </p:nvSpPr>
         <p:spPr>
           <a:xfrm>
-            <a:off x="4297680" y="4114800"/>
-            <a:ext cx="3474720" cy="1463040"/>
+            <a:off x="594360" y="4842764"/>
+            <a:ext cx="3474720" cy="987552"/>
           </a:xfrm>
           <a:prstGeom prst="rect">
             <a:avLst/>
@@ -5323,9 +5413,9 @@
           <a:solidFill>
             <a:srgbClr val="FFFFFF"/>
           </a:solidFill>
-          <a:ln w="25400">
+          <a:ln w="22860">
             <a:solidFill>
-              <a:srgbClr val="275BC4"/>
+              <a:srgbClr val="2563EB"/>
             </a:solidFill>
           </a:ln>
         </p:spPr>
@@ -5353,20 +5443,56 @@
       </p:sp>
       <p:sp>
         <p:nvSpPr>
-          <p:cNvPr id="25" name="Rectangle 24"/>
+          <p:cNvPr id="19" name="TextBox 18"/>
+          <p:cNvSpPr txBox="1"/>
+          <p:nvPr/>
+        </p:nvSpPr>
+        <p:spPr>
+          <a:xfrm>
+            <a:off x="722376" y="4970780"/>
+            <a:ext cx="3218688" cy="786384"/>
+          </a:xfrm>
+          <a:prstGeom prst="rect">
+            <a:avLst/>
+          </a:prstGeom>
+          <a:noFill/>
+        </p:spPr>
+        <p:txBody>
+          <a:bodyPr wrap="square">
+            <a:spAutoFit/>
+          </a:bodyPr>
+          <a:lstStyle/>
+          <a:p>
+            <a:pPr algn="ctr"/>
+            <a:r>
+              <a:rPr sz="1200" b="1" i="0">
+                <a:solidFill>
+                  <a:srgbClr val="1E3A8A"/>
+                </a:solidFill>
+                <a:latin typeface="IPAGothic"/>
+              </a:rPr>
+              <a:t>短期で成果出しの
+検証まで実行できる</a:t>
+            </a:r>
+          </a:p>
+        </p:txBody>
+      </p:sp>
+      <p:sp>
+        <p:nvSpPr>
+          <p:cNvPr id="20" name="Rectangle 19"/>
           <p:cNvSpPr/>
           <p:nvPr/>
         </p:nvSpPr>
         <p:spPr>
           <a:xfrm>
-            <a:off x="5669280" y="3886200"/>
-            <a:ext cx="731520" cy="457200"/>
+            <a:off x="4261104" y="1508760"/>
+            <a:ext cx="3474720" cy="1078992"/>
           </a:xfrm>
           <a:prstGeom prst="rect">
             <a:avLst/>
           </a:prstGeom>
           <a:solidFill>
-            <a:srgbClr val="1E3A6E"/>
+            <a:srgbClr val="1E3A8A"/>
           </a:solidFill>
           <a:ln>
             <a:noFill/>
@@ -5387,32 +5513,23 @@
           </a:fontRef>
         </p:style>
         <p:txBody>
-          <a:bodyPr rtlCol="0" anchor="ctr" wrap="square"/>
+          <a:bodyPr rtlCol="0" anchor="ctr"/>
           <a:lstStyle/>
           <a:p>
             <a:pPr algn="ctr"/>
-            <a:r>
-              <a:rPr sz="800" b="1">
-                <a:solidFill>
-                  <a:srgbClr val="FFFFFF"/>
-                </a:solidFill>
-              </a:rPr>
-              <a:t>利点
-02</a:t>
-            </a:r>
-          </a:p>
-        </p:txBody>
-      </p:sp>
-      <p:sp>
-        <p:nvSpPr>
-          <p:cNvPr id="26" name="TextBox 25"/>
+          </a:p>
+        </p:txBody>
+      </p:sp>
+      <p:sp>
+        <p:nvSpPr>
+          <p:cNvPr id="21" name="TextBox 20"/>
           <p:cNvSpPr txBox="1"/>
           <p:nvPr/>
         </p:nvSpPr>
         <p:spPr>
           <a:xfrm>
-            <a:off x="4389120" y="4389120"/>
-            <a:ext cx="3291840" cy="1005840"/>
+            <a:off x="4425696" y="1618488"/>
+            <a:ext cx="3291840" cy="256032"/>
           </a:xfrm>
           <a:prstGeom prst="rect">
             <a:avLst/>
@@ -5427,38 +5544,107 @@
           <a:p>
             <a:pPr algn="ctr"/>
             <a:r>
-              <a:rPr sz="1200" b="1">
-                <a:solidFill>
-                  <a:srgbClr val="1E3A6E"/>
-                </a:solidFill>
-                <a:latin typeface="Noto Sans JP"/>
+              <a:rPr sz="900" b="1" i="0">
+                <a:solidFill>
+                  <a:srgbClr val="3B82F6"/>
+                </a:solidFill>
+                <a:latin typeface="Calibri"/>
               </a:rPr>
-              <a:t>成功体験を経て
-要領がわかる</a:t>
-            </a:r>
-          </a:p>
-        </p:txBody>
-      </p:sp>
-      <p:sp>
-        <p:nvSpPr>
-          <p:cNvPr id="27" name="Rectangle 26"/>
+              <a:t>ACTION  02</a:t>
+            </a:r>
+          </a:p>
+        </p:txBody>
+      </p:sp>
+      <p:sp>
+        <p:nvSpPr>
+          <p:cNvPr id="22" name="TextBox 21"/>
+          <p:cNvSpPr txBox="1"/>
+          <p:nvPr/>
+        </p:nvSpPr>
+        <p:spPr>
+          <a:xfrm>
+            <a:off x="4370832" y="1892808"/>
+            <a:ext cx="3255264" cy="621792"/>
+          </a:xfrm>
+          <a:prstGeom prst="rect">
+            <a:avLst/>
+          </a:prstGeom>
+          <a:noFill/>
+        </p:spPr>
+        <p:txBody>
+          <a:bodyPr wrap="square">
+            <a:spAutoFit/>
+          </a:bodyPr>
+          <a:lstStyle/>
+          <a:p>
+            <a:pPr algn="ctr"/>
+            <a:r>
+              <a:rPr sz="1600" b="1" i="0">
+                <a:solidFill>
+                  <a:srgbClr val="FFFFFF"/>
+                </a:solidFill>
+                <a:latin typeface="IPAGothic"/>
+              </a:rPr>
+              <a:t>仕組み実装</a:t>
+            </a:r>
+          </a:p>
+        </p:txBody>
+      </p:sp>
+      <p:sp>
+        <p:nvSpPr>
+          <p:cNvPr id="23" name="TextBox 22"/>
+          <p:cNvSpPr txBox="1"/>
+          <p:nvPr/>
+        </p:nvSpPr>
+        <p:spPr>
+          <a:xfrm>
+            <a:off x="7772400" y="1874520"/>
+            <a:ext cx="301752" cy="365760"/>
+          </a:xfrm>
+          <a:prstGeom prst="rect">
+            <a:avLst/>
+          </a:prstGeom>
+          <a:noFill/>
+        </p:spPr>
+        <p:txBody>
+          <a:bodyPr wrap="square">
+            <a:spAutoFit/>
+          </a:bodyPr>
+          <a:lstStyle/>
+          <a:p>
+            <a:pPr algn="ctr"/>
+            <a:r>
+              <a:rPr sz="1100" b="0" i="0">
+                <a:solidFill>
+                  <a:srgbClr val="1E3A8A"/>
+                </a:solidFill>
+                <a:latin typeface="Calibri"/>
+              </a:rPr>
+              <a:t>▶</a:t>
+            </a:r>
+          </a:p>
+        </p:txBody>
+      </p:sp>
+      <p:sp>
+        <p:nvSpPr>
+          <p:cNvPr id="24" name="Rectangle 23"/>
           <p:cNvSpPr/>
           <p:nvPr/>
         </p:nvSpPr>
         <p:spPr>
           <a:xfrm>
-            <a:off x="8229600" y="4114800"/>
-            <a:ext cx="3474720" cy="1463040"/>
+            <a:off x="4261104" y="2715768"/>
+            <a:ext cx="3474720" cy="1572768"/>
           </a:xfrm>
           <a:prstGeom prst="rect">
             <a:avLst/>
           </a:prstGeom>
           <a:solidFill>
-            <a:srgbClr val="FFFFFF"/>
+            <a:srgbClr val="EFF4FF"/>
           </a:solidFill>
-          <a:ln w="25400">
+          <a:ln w="10160">
             <a:solidFill>
-              <a:srgbClr val="275BC4"/>
+              <a:srgbClr val="DBEAFE"/>
             </a:solidFill>
           </a:ln>
         </p:spPr>
@@ -5486,20 +5672,58 @@
       </p:sp>
       <p:sp>
         <p:nvSpPr>
-          <p:cNvPr id="28" name="Rectangle 27"/>
+          <p:cNvPr id="25" name="TextBox 24"/>
+          <p:cNvSpPr txBox="1"/>
+          <p:nvPr/>
+        </p:nvSpPr>
+        <p:spPr>
+          <a:xfrm>
+            <a:off x="4425696" y="2825496"/>
+            <a:ext cx="3218688" cy="1389888"/>
+          </a:xfrm>
+          <a:prstGeom prst="rect">
+            <a:avLst/>
+          </a:prstGeom>
+          <a:noFill/>
+        </p:spPr>
+        <p:txBody>
+          <a:bodyPr wrap="square">
+            <a:spAutoFit/>
+          </a:bodyPr>
+          <a:lstStyle/>
+          <a:p>
+            <a:pPr algn="l"/>
+            <a:r>
+              <a:rPr sz="950" b="0" i="0">
+                <a:solidFill>
+                  <a:srgbClr val="0F172A"/>
+                </a:solidFill>
+                <a:latin typeface="IPAGothic"/>
+              </a:rPr>
+              <a:t>・Key アクションを KPI に実装
+・会議体・ダッシュボード設計
+・現場への運用説明会の実施
+・管理職トレーニング</a:t>
+            </a:r>
+          </a:p>
+        </p:txBody>
+      </p:sp>
+      <p:sp>
+        <p:nvSpPr>
+          <p:cNvPr id="26" name="Rectangle 25"/>
           <p:cNvSpPr/>
           <p:nvPr/>
         </p:nvSpPr>
         <p:spPr>
           <a:xfrm>
-            <a:off x="9601200" y="3886200"/>
-            <a:ext cx="731520" cy="457200"/>
+            <a:off x="5449824" y="4562856"/>
+            <a:ext cx="1097280" cy="292608"/>
           </a:xfrm>
           <a:prstGeom prst="rect">
             <a:avLst/>
           </a:prstGeom>
           <a:solidFill>
-            <a:srgbClr val="1E3A6E"/>
+            <a:srgbClr val="1E3A8A"/>
           </a:solidFill>
           <a:ln>
             <a:noFill/>
@@ -5529,23 +5753,68 @@
                 <a:solidFill>
                   <a:srgbClr val="FFFFFF"/>
                 </a:solidFill>
+                <a:latin typeface="IPAGothic"/>
               </a:rPr>
-              <a:t>利点
-03</a:t>
-            </a:r>
-          </a:p>
-        </p:txBody>
-      </p:sp>
-      <p:sp>
-        <p:nvSpPr>
-          <p:cNvPr id="29" name="TextBox 28"/>
+              <a:t>利点  02</a:t>
+            </a:r>
+          </a:p>
+        </p:txBody>
+      </p:sp>
+      <p:sp>
+        <p:nvSpPr>
+          <p:cNvPr id="27" name="Rectangle 26"/>
+          <p:cNvSpPr/>
+          <p:nvPr/>
+        </p:nvSpPr>
+        <p:spPr>
+          <a:xfrm>
+            <a:off x="4261104" y="4842764"/>
+            <a:ext cx="3474720" cy="987552"/>
+          </a:xfrm>
+          <a:prstGeom prst="rect">
+            <a:avLst/>
+          </a:prstGeom>
+          <a:solidFill>
+            <a:srgbClr val="FFFFFF"/>
+          </a:solidFill>
+          <a:ln w="22860">
+            <a:solidFill>
+              <a:srgbClr val="2563EB"/>
+            </a:solidFill>
+          </a:ln>
+        </p:spPr>
+        <p:style>
+          <a:lnRef idx="1">
+            <a:schemeClr val="accent1"/>
+          </a:lnRef>
+          <a:fillRef idx="3">
+            <a:schemeClr val="accent1"/>
+          </a:fillRef>
+          <a:effectRef idx="2">
+            <a:schemeClr val="accent1"/>
+          </a:effectRef>
+          <a:fontRef idx="minor">
+            <a:schemeClr val="lt1"/>
+          </a:fontRef>
+        </p:style>
+        <p:txBody>
+          <a:bodyPr rtlCol="0" anchor="ctr"/>
+          <a:lstStyle/>
+          <a:p>
+            <a:pPr algn="ctr"/>
+          </a:p>
+        </p:txBody>
+      </p:sp>
+      <p:sp>
+        <p:nvSpPr>
+          <p:cNvPr id="28" name="TextBox 27"/>
           <p:cNvSpPr txBox="1"/>
           <p:nvPr/>
         </p:nvSpPr>
         <p:spPr>
           <a:xfrm>
-            <a:off x="8321040" y="4389120"/>
-            <a:ext cx="3291840" cy="1005840"/>
+            <a:off x="4389120" y="4970780"/>
+            <a:ext cx="3218688" cy="786384"/>
           </a:xfrm>
           <a:prstGeom prst="rect">
             <a:avLst/>
@@ -5560,14 +5829,343 @@
           <a:p>
             <a:pPr algn="ctr"/>
             <a:r>
-              <a:rPr sz="1200" b="1">
-                <a:solidFill>
-                  <a:srgbClr val="1E3A6E"/>
-                </a:solidFill>
-                <a:latin typeface="Noto Sans JP"/>
+              <a:rPr sz="1200" b="1" i="0">
+                <a:solidFill>
+                  <a:srgbClr val="1E3A8A"/>
+                </a:solidFill>
+                <a:latin typeface="IPAGothic"/>
+              </a:rPr>
+              <a:t>成功体験を経て
+要領がわかる</a:t>
+            </a:r>
+          </a:p>
+        </p:txBody>
+      </p:sp>
+      <p:sp>
+        <p:nvSpPr>
+          <p:cNvPr id="29" name="Rectangle 28"/>
+          <p:cNvSpPr/>
+          <p:nvPr/>
+        </p:nvSpPr>
+        <p:spPr>
+          <a:xfrm>
+            <a:off x="7927848" y="1508760"/>
+            <a:ext cx="3474720" cy="1078992"/>
+          </a:xfrm>
+          <a:prstGeom prst="rect">
+            <a:avLst/>
+          </a:prstGeom>
+          <a:solidFill>
+            <a:srgbClr val="1E3A8A"/>
+          </a:solidFill>
+          <a:ln>
+            <a:noFill/>
+          </a:ln>
+        </p:spPr>
+        <p:style>
+          <a:lnRef idx="1">
+            <a:schemeClr val="accent1"/>
+          </a:lnRef>
+          <a:fillRef idx="3">
+            <a:schemeClr val="accent1"/>
+          </a:fillRef>
+          <a:effectRef idx="2">
+            <a:schemeClr val="accent1"/>
+          </a:effectRef>
+          <a:fontRef idx="minor">
+            <a:schemeClr val="lt1"/>
+          </a:fontRef>
+        </p:style>
+        <p:txBody>
+          <a:bodyPr rtlCol="0" anchor="ctr"/>
+          <a:lstStyle/>
+          <a:p>
+            <a:pPr algn="ctr"/>
+          </a:p>
+        </p:txBody>
+      </p:sp>
+      <p:sp>
+        <p:nvSpPr>
+          <p:cNvPr id="30" name="TextBox 29"/>
+          <p:cNvSpPr txBox="1"/>
+          <p:nvPr/>
+        </p:nvSpPr>
+        <p:spPr>
+          <a:xfrm>
+            <a:off x="8092440" y="1618488"/>
+            <a:ext cx="3291840" cy="256032"/>
+          </a:xfrm>
+          <a:prstGeom prst="rect">
+            <a:avLst/>
+          </a:prstGeom>
+          <a:noFill/>
+        </p:spPr>
+        <p:txBody>
+          <a:bodyPr wrap="square">
+            <a:spAutoFit/>
+          </a:bodyPr>
+          <a:lstStyle/>
+          <a:p>
+            <a:pPr algn="ctr"/>
+            <a:r>
+              <a:rPr sz="900" b="1" i="0">
+                <a:solidFill>
+                  <a:srgbClr val="3B82F6"/>
+                </a:solidFill>
+                <a:latin typeface="Calibri"/>
+              </a:rPr>
+              <a:t>ACTION  03</a:t>
+            </a:r>
+          </a:p>
+        </p:txBody>
+      </p:sp>
+      <p:sp>
+        <p:nvSpPr>
+          <p:cNvPr id="31" name="TextBox 30"/>
+          <p:cNvSpPr txBox="1"/>
+          <p:nvPr/>
+        </p:nvSpPr>
+        <p:spPr>
+          <a:xfrm>
+            <a:off x="8037576" y="1892808"/>
+            <a:ext cx="3255264" cy="621792"/>
+          </a:xfrm>
+          <a:prstGeom prst="rect">
+            <a:avLst/>
+          </a:prstGeom>
+          <a:noFill/>
+        </p:spPr>
+        <p:txBody>
+          <a:bodyPr wrap="square">
+            <a:spAutoFit/>
+          </a:bodyPr>
+          <a:lstStyle/>
+          <a:p>
+            <a:pPr algn="ctr"/>
+            <a:r>
+              <a:rPr sz="1600" b="1" i="0">
+                <a:solidFill>
+                  <a:srgbClr val="FFFFFF"/>
+                </a:solidFill>
+                <a:latin typeface="IPAGothic"/>
+              </a:rPr>
+              <a:t>習慣化・定着</a:t>
+            </a:r>
+          </a:p>
+        </p:txBody>
+      </p:sp>
+      <p:sp>
+        <p:nvSpPr>
+          <p:cNvPr id="32" name="Rectangle 31"/>
+          <p:cNvSpPr/>
+          <p:nvPr/>
+        </p:nvSpPr>
+        <p:spPr>
+          <a:xfrm>
+            <a:off x="7927848" y="2715768"/>
+            <a:ext cx="3474720" cy="1572768"/>
+          </a:xfrm>
+          <a:prstGeom prst="rect">
+            <a:avLst/>
+          </a:prstGeom>
+          <a:solidFill>
+            <a:srgbClr val="EFF4FF"/>
+          </a:solidFill>
+          <a:ln w="10160">
+            <a:solidFill>
+              <a:srgbClr val="DBEAFE"/>
+            </a:solidFill>
+          </a:ln>
+        </p:spPr>
+        <p:style>
+          <a:lnRef idx="1">
+            <a:schemeClr val="accent1"/>
+          </a:lnRef>
+          <a:fillRef idx="3">
+            <a:schemeClr val="accent1"/>
+          </a:fillRef>
+          <a:effectRef idx="2">
+            <a:schemeClr val="accent1"/>
+          </a:effectRef>
+          <a:fontRef idx="minor">
+            <a:schemeClr val="lt1"/>
+          </a:fontRef>
+        </p:style>
+        <p:txBody>
+          <a:bodyPr rtlCol="0" anchor="ctr"/>
+          <a:lstStyle/>
+          <a:p>
+            <a:pPr algn="ctr"/>
+          </a:p>
+        </p:txBody>
+      </p:sp>
+      <p:sp>
+        <p:nvSpPr>
+          <p:cNvPr id="33" name="TextBox 32"/>
+          <p:cNvSpPr txBox="1"/>
+          <p:nvPr/>
+        </p:nvSpPr>
+        <p:spPr>
+          <a:xfrm>
+            <a:off x="8092440" y="2825496"/>
+            <a:ext cx="3218688" cy="1389888"/>
+          </a:xfrm>
+          <a:prstGeom prst="rect">
+            <a:avLst/>
+          </a:prstGeom>
+          <a:noFill/>
+        </p:spPr>
+        <p:txBody>
+          <a:bodyPr wrap="square">
+            <a:spAutoFit/>
+          </a:bodyPr>
+          <a:lstStyle/>
+          <a:p>
+            <a:pPr algn="l"/>
+            <a:r>
+              <a:rPr sz="950" b="0" i="0">
+                <a:solidFill>
+                  <a:srgbClr val="0F172A"/>
+                </a:solidFill>
+                <a:latin typeface="IPAGothic"/>
+              </a:rPr>
+              <a:t>・日々の会議体で進捗確認
+・ブロッカーをタイムリー排除
+・アジャイルに磨き込み
+・効果測定と横展開</a:t>
+            </a:r>
+          </a:p>
+        </p:txBody>
+      </p:sp>
+      <p:sp>
+        <p:nvSpPr>
+          <p:cNvPr id="34" name="Rectangle 33"/>
+          <p:cNvSpPr/>
+          <p:nvPr/>
+        </p:nvSpPr>
+        <p:spPr>
+          <a:xfrm>
+            <a:off x="9116568" y="4562856"/>
+            <a:ext cx="1097280" cy="292608"/>
+          </a:xfrm>
+          <a:prstGeom prst="rect">
+            <a:avLst/>
+          </a:prstGeom>
+          <a:solidFill>
+            <a:srgbClr val="1E3A8A"/>
+          </a:solidFill>
+          <a:ln>
+            <a:noFill/>
+          </a:ln>
+        </p:spPr>
+        <p:style>
+          <a:lnRef idx="1">
+            <a:schemeClr val="accent1"/>
+          </a:lnRef>
+          <a:fillRef idx="3">
+            <a:schemeClr val="accent1"/>
+          </a:fillRef>
+          <a:effectRef idx="2">
+            <a:schemeClr val="accent1"/>
+          </a:effectRef>
+          <a:fontRef idx="minor">
+            <a:schemeClr val="lt1"/>
+          </a:fontRef>
+        </p:style>
+        <p:txBody>
+          <a:bodyPr rtlCol="0" anchor="ctr" wrap="square"/>
+          <a:lstStyle/>
+          <a:p>
+            <a:pPr algn="ctr"/>
+            <a:r>
+              <a:rPr sz="800" b="1">
+                <a:solidFill>
+                  <a:srgbClr val="FFFFFF"/>
+                </a:solidFill>
+                <a:latin typeface="IPAGothic"/>
+              </a:rPr>
+              <a:t>利点  03</a:t>
+            </a:r>
+          </a:p>
+        </p:txBody>
+      </p:sp>
+      <p:sp>
+        <p:nvSpPr>
+          <p:cNvPr id="35" name="Rectangle 34"/>
+          <p:cNvSpPr/>
+          <p:nvPr/>
+        </p:nvSpPr>
+        <p:spPr>
+          <a:xfrm>
+            <a:off x="7927848" y="4842764"/>
+            <a:ext cx="3474720" cy="987552"/>
+          </a:xfrm>
+          <a:prstGeom prst="rect">
+            <a:avLst/>
+          </a:prstGeom>
+          <a:solidFill>
+            <a:srgbClr val="FFFFFF"/>
+          </a:solidFill>
+          <a:ln w="22860">
+            <a:solidFill>
+              <a:srgbClr val="2563EB"/>
+            </a:solidFill>
+          </a:ln>
+        </p:spPr>
+        <p:style>
+          <a:lnRef idx="1">
+            <a:schemeClr val="accent1"/>
+          </a:lnRef>
+          <a:fillRef idx="3">
+            <a:schemeClr val="accent1"/>
+          </a:fillRef>
+          <a:effectRef idx="2">
+            <a:schemeClr val="accent1"/>
+          </a:effectRef>
+          <a:fontRef idx="minor">
+            <a:schemeClr val="lt1"/>
+          </a:fontRef>
+        </p:style>
+        <p:txBody>
+          <a:bodyPr rtlCol="0" anchor="ctr"/>
+          <a:lstStyle/>
+          <a:p>
+            <a:pPr algn="ctr"/>
+          </a:p>
+        </p:txBody>
+      </p:sp>
+      <p:sp>
+        <p:nvSpPr>
+          <p:cNvPr id="36" name="TextBox 35"/>
+          <p:cNvSpPr txBox="1"/>
+          <p:nvPr/>
+        </p:nvSpPr>
+        <p:spPr>
+          <a:xfrm>
+            <a:off x="8055864" y="4970780"/>
+            <a:ext cx="3218688" cy="786384"/>
+          </a:xfrm>
+          <a:prstGeom prst="rect">
+            <a:avLst/>
+          </a:prstGeom>
+          <a:noFill/>
+        </p:spPr>
+        <p:txBody>
+          <a:bodyPr wrap="square">
+            <a:spAutoFit/>
+          </a:bodyPr>
+          <a:lstStyle/>
+          <a:p>
+            <a:pPr algn="ctr"/>
+            <a:r>
+              <a:rPr sz="1200" b="1" i="0">
+                <a:solidFill>
+                  <a:srgbClr val="1E3A8A"/>
+                </a:solidFill>
+                <a:latin typeface="IPAGothic"/>
               </a:rPr>
               <a:t>戦略を実行する習慣が
-形成され成果にHITする</a:t>
+形成され成果に HIT する</a:t>
             </a:r>
           </a:p>
         </p:txBody>

</xml_diff>